<commit_message>
Rebuild PowerPoint with dynamic row heights and larger description font
Co-Authored-By: Claude Sonnet 4.6 <noreply@anthropic.com>
</commit_message>
<xml_diff>
--- a/Simon_Cheng_OKR_2026.pptx
+++ b/Simon_Cheng_OKR_2026.pptx
@@ -3142,7 +3142,7 @@
         <p:spPr>
           <a:xfrm>
             <a:off x="0" y="0"/>
-            <a:ext cx="12188952" cy="256032"/>
+            <a:ext cx="12188952" cy="292608"/>
           </a:xfrm>
           <a:prstGeom prst="rect">
             <a:avLst/>
@@ -3184,7 +3184,7 @@
         </p:nvSpPr>
         <p:spPr>
           <a:xfrm>
-            <a:off x="0" y="256032"/>
+            <a:off x="0" y="292608"/>
             <a:ext cx="12188952" cy="25400"/>
           </a:xfrm>
           <a:prstGeom prst="rect">
@@ -3227,23 +3227,23 @@
         </p:nvSpPr>
         <p:spPr>
           <a:xfrm>
-            <a:off x="256032" y="45720"/>
-            <a:ext cx="7315200" cy="256032"/>
-          </a:xfrm>
-          <a:prstGeom prst="rect">
-            <a:avLst/>
-          </a:prstGeom>
-          <a:noFill/>
-        </p:spPr>
-        <p:txBody>
-          <a:bodyPr wrap="square">
-            <a:spAutoFit/>
-          </a:bodyPr>
-          <a:lstStyle/>
-          <a:p>
-            <a:pPr algn="l"/>
-            <a:r>
-              <a:rPr sz="800" b="0" i="0">
+            <a:off x="292608" y="64008"/>
+            <a:ext cx="7315200" cy="292608"/>
+          </a:xfrm>
+          <a:prstGeom prst="rect">
+            <a:avLst/>
+          </a:prstGeom>
+          <a:noFill/>
+        </p:spPr>
+        <p:txBody>
+          <a:bodyPr wrap="square">
+            <a:spAutoFit/>
+          </a:bodyPr>
+          <a:lstStyle/>
+          <a:p>
+            <a:pPr algn="l"/>
+            <a:r>
+              <a:rPr sz="900" b="0" i="0">
                 <a:solidFill>
                   <a:srgbClr val="FFFFFF"/>
                 </a:solidFill>
@@ -3262,8 +3262,8 @@
         </p:nvSpPr>
         <p:spPr>
           <a:xfrm>
-            <a:off x="11548872" y="45720"/>
-            <a:ext cx="457200" cy="256032"/>
+            <a:off x="11548872" y="64008"/>
+            <a:ext cx="457200" cy="292608"/>
           </a:xfrm>
           <a:prstGeom prst="rect">
             <a:avLst/>
@@ -3297,8 +3297,8 @@
         </p:nvSpPr>
         <p:spPr>
           <a:xfrm>
-            <a:off x="0" y="294132"/>
-            <a:ext cx="12188952" cy="201168"/>
+            <a:off x="0" y="330708"/>
+            <a:ext cx="12188952" cy="237744"/>
           </a:xfrm>
           <a:prstGeom prst="rect">
             <a:avLst/>
@@ -3340,23 +3340,23 @@
         </p:nvSpPr>
         <p:spPr>
           <a:xfrm>
-            <a:off x="256032" y="321564"/>
-            <a:ext cx="4818888" cy="201168"/>
-          </a:xfrm>
-          <a:prstGeom prst="rect">
-            <a:avLst/>
-          </a:prstGeom>
-          <a:noFill/>
-        </p:spPr>
-        <p:txBody>
-          <a:bodyPr wrap="square">
-            <a:spAutoFit/>
-          </a:bodyPr>
-          <a:lstStyle/>
-          <a:p>
-            <a:pPr algn="l"/>
-            <a:r>
-              <a:rPr sz="800" b="1" i="0">
+            <a:off x="292608" y="367284"/>
+            <a:ext cx="4608576" cy="201168"/>
+          </a:xfrm>
+          <a:prstGeom prst="rect">
+            <a:avLst/>
+          </a:prstGeom>
+          <a:noFill/>
+        </p:spPr>
+        <p:txBody>
+          <a:bodyPr wrap="square">
+            <a:spAutoFit/>
+          </a:bodyPr>
+          <a:lstStyle/>
+          <a:p>
+            <a:pPr algn="l"/>
+            <a:r>
+              <a:rPr sz="900" b="1" i="0">
                 <a:solidFill>
                   <a:srgbClr val="FFFFFF"/>
                 </a:solidFill>
@@ -3375,8 +3375,8 @@
         </p:nvSpPr>
         <p:spPr>
           <a:xfrm>
-            <a:off x="0" y="495300"/>
-            <a:ext cx="12188952" cy="640080"/>
+            <a:off x="0" y="568452"/>
+            <a:ext cx="12188952" cy="627718"/>
           </a:xfrm>
           <a:prstGeom prst="rect">
             <a:avLst/>
@@ -3418,8 +3418,8 @@
         </p:nvSpPr>
         <p:spPr>
           <a:xfrm>
-            <a:off x="256032" y="531876"/>
-            <a:ext cx="4773168" cy="146304"/>
+            <a:off x="292608" y="623316"/>
+            <a:ext cx="4562856" cy="164592"/>
           </a:xfrm>
           <a:prstGeom prst="rect">
             <a:avLst/>
@@ -3453,8 +3453,8 @@
         </p:nvSpPr>
         <p:spPr>
           <a:xfrm>
-            <a:off x="256032" y="696468"/>
-            <a:ext cx="4773168" cy="420624"/>
+            <a:off x="292608" y="824484"/>
+            <a:ext cx="4562856" cy="316822"/>
           </a:xfrm>
           <a:prstGeom prst="rect">
             <a:avLst/>
@@ -3488,8 +3488,8 @@
         </p:nvSpPr>
         <p:spPr>
           <a:xfrm>
-            <a:off x="5120640" y="541020"/>
-            <a:ext cx="2194560" cy="548640"/>
+            <a:off x="4956048" y="623316"/>
+            <a:ext cx="2221992" cy="517990"/>
           </a:xfrm>
           <a:prstGeom prst="rect">
             <a:avLst/>
@@ -3531,8 +3531,8 @@
         </p:nvSpPr>
         <p:spPr>
           <a:xfrm>
-            <a:off x="5184648" y="568452"/>
-            <a:ext cx="2194560" cy="128016"/>
+            <a:off x="5029200" y="659892"/>
+            <a:ext cx="2221992" cy="137160"/>
           </a:xfrm>
           <a:prstGeom prst="rect">
             <a:avLst/>
@@ -3566,8 +3566,8 @@
         </p:nvSpPr>
         <p:spPr>
           <a:xfrm>
-            <a:off x="5184648" y="705612"/>
-            <a:ext cx="2121408" cy="365760"/>
+            <a:off x="5029200" y="824484"/>
+            <a:ext cx="2148840" cy="289390"/>
           </a:xfrm>
           <a:prstGeom prst="rect">
             <a:avLst/>
@@ -3601,8 +3601,8 @@
         </p:nvSpPr>
         <p:spPr>
           <a:xfrm>
-            <a:off x="7406640" y="541020"/>
-            <a:ext cx="2194560" cy="548640"/>
+            <a:off x="7287768" y="623316"/>
+            <a:ext cx="2221992" cy="517990"/>
           </a:xfrm>
           <a:prstGeom prst="rect">
             <a:avLst/>
@@ -3644,8 +3644,8 @@
         </p:nvSpPr>
         <p:spPr>
           <a:xfrm>
-            <a:off x="7470648" y="568452"/>
-            <a:ext cx="2194560" cy="128016"/>
+            <a:off x="7360920" y="659892"/>
+            <a:ext cx="2221992" cy="137160"/>
           </a:xfrm>
           <a:prstGeom prst="rect">
             <a:avLst/>
@@ -3679,8 +3679,8 @@
         </p:nvSpPr>
         <p:spPr>
           <a:xfrm>
-            <a:off x="7470648" y="705612"/>
-            <a:ext cx="2121408" cy="365760"/>
+            <a:off x="7360920" y="824484"/>
+            <a:ext cx="2148840" cy="289390"/>
           </a:xfrm>
           <a:prstGeom prst="rect">
             <a:avLst/>
@@ -3714,8 +3714,8 @@
         </p:nvSpPr>
         <p:spPr>
           <a:xfrm>
-            <a:off x="9692640" y="541020"/>
-            <a:ext cx="2194560" cy="548640"/>
+            <a:off x="9619488" y="623316"/>
+            <a:ext cx="2221992" cy="517990"/>
           </a:xfrm>
           <a:prstGeom prst="rect">
             <a:avLst/>
@@ -3757,8 +3757,8 @@
         </p:nvSpPr>
         <p:spPr>
           <a:xfrm>
-            <a:off x="9756648" y="568452"/>
-            <a:ext cx="2194560" cy="128016"/>
+            <a:off x="9692640" y="659892"/>
+            <a:ext cx="2221992" cy="137160"/>
           </a:xfrm>
           <a:prstGeom prst="rect">
             <a:avLst/>
@@ -3792,8 +3792,8 @@
         </p:nvSpPr>
         <p:spPr>
           <a:xfrm>
-            <a:off x="9756648" y="705612"/>
-            <a:ext cx="2121408" cy="365760"/>
+            <a:off x="9692640" y="824484"/>
+            <a:ext cx="2148840" cy="289390"/>
           </a:xfrm>
           <a:prstGeom prst="rect">
             <a:avLst/>
@@ -3827,7 +3827,7 @@
         </p:nvSpPr>
         <p:spPr>
           <a:xfrm>
-            <a:off x="0" y="1129030"/>
+            <a:off x="0" y="1189820"/>
             <a:ext cx="12188952" cy="6350"/>
           </a:xfrm>
           <a:prstGeom prst="rect">
@@ -3870,8 +3870,8 @@
         </p:nvSpPr>
         <p:spPr>
           <a:xfrm>
-            <a:off x="0" y="1135380"/>
-            <a:ext cx="12188952" cy="640080"/>
+            <a:off x="0" y="1196170"/>
+            <a:ext cx="12188952" cy="627718"/>
           </a:xfrm>
           <a:prstGeom prst="rect">
             <a:avLst/>
@@ -3913,8 +3913,8 @@
         </p:nvSpPr>
         <p:spPr>
           <a:xfrm>
-            <a:off x="256032" y="1171956"/>
-            <a:ext cx="4773168" cy="146304"/>
+            <a:off x="292608" y="1251034"/>
+            <a:ext cx="4562856" cy="164592"/>
           </a:xfrm>
           <a:prstGeom prst="rect">
             <a:avLst/>
@@ -3948,8 +3948,8 @@
         </p:nvSpPr>
         <p:spPr>
           <a:xfrm>
-            <a:off x="256032" y="1336548"/>
-            <a:ext cx="4773168" cy="420624"/>
+            <a:off x="292608" y="1452202"/>
+            <a:ext cx="4562856" cy="316822"/>
           </a:xfrm>
           <a:prstGeom prst="rect">
             <a:avLst/>
@@ -3983,8 +3983,8 @@
         </p:nvSpPr>
         <p:spPr>
           <a:xfrm>
-            <a:off x="5120640" y="1181100"/>
-            <a:ext cx="2194560" cy="548640"/>
+            <a:off x="4956048" y="1251034"/>
+            <a:ext cx="2221992" cy="517990"/>
           </a:xfrm>
           <a:prstGeom prst="rect">
             <a:avLst/>
@@ -4026,8 +4026,8 @@
         </p:nvSpPr>
         <p:spPr>
           <a:xfrm>
-            <a:off x="5184648" y="1208532"/>
-            <a:ext cx="2194560" cy="128016"/>
+            <a:off x="5029200" y="1287610"/>
+            <a:ext cx="2221992" cy="137160"/>
           </a:xfrm>
           <a:prstGeom prst="rect">
             <a:avLst/>
@@ -4061,8 +4061,8 @@
         </p:nvSpPr>
         <p:spPr>
           <a:xfrm>
-            <a:off x="5184648" y="1345692"/>
-            <a:ext cx="2121408" cy="365760"/>
+            <a:off x="5029200" y="1452202"/>
+            <a:ext cx="2148840" cy="289390"/>
           </a:xfrm>
           <a:prstGeom prst="rect">
             <a:avLst/>
@@ -4096,8 +4096,8 @@
         </p:nvSpPr>
         <p:spPr>
           <a:xfrm>
-            <a:off x="7406640" y="1181100"/>
-            <a:ext cx="2194560" cy="548640"/>
+            <a:off x="7287768" y="1251034"/>
+            <a:ext cx="2221992" cy="517990"/>
           </a:xfrm>
           <a:prstGeom prst="rect">
             <a:avLst/>
@@ -4139,8 +4139,8 @@
         </p:nvSpPr>
         <p:spPr>
           <a:xfrm>
-            <a:off x="7470648" y="1208532"/>
-            <a:ext cx="2194560" cy="128016"/>
+            <a:off x="7360920" y="1287610"/>
+            <a:ext cx="2221992" cy="137160"/>
           </a:xfrm>
           <a:prstGeom prst="rect">
             <a:avLst/>
@@ -4174,8 +4174,8 @@
         </p:nvSpPr>
         <p:spPr>
           <a:xfrm>
-            <a:off x="7470648" y="1345692"/>
-            <a:ext cx="2121408" cy="365760"/>
+            <a:off x="7360920" y="1452202"/>
+            <a:ext cx="2148840" cy="289390"/>
           </a:xfrm>
           <a:prstGeom prst="rect">
             <a:avLst/>
@@ -4209,8 +4209,8 @@
         </p:nvSpPr>
         <p:spPr>
           <a:xfrm>
-            <a:off x="9692640" y="1181100"/>
-            <a:ext cx="2194560" cy="548640"/>
+            <a:off x="9619488" y="1251034"/>
+            <a:ext cx="2221992" cy="517990"/>
           </a:xfrm>
           <a:prstGeom prst="rect">
             <a:avLst/>
@@ -4252,8 +4252,8 @@
         </p:nvSpPr>
         <p:spPr>
           <a:xfrm>
-            <a:off x="9756648" y="1208532"/>
-            <a:ext cx="2194560" cy="128016"/>
+            <a:off x="9692640" y="1287610"/>
+            <a:ext cx="2221992" cy="137160"/>
           </a:xfrm>
           <a:prstGeom prst="rect">
             <a:avLst/>
@@ -4287,8 +4287,8 @@
         </p:nvSpPr>
         <p:spPr>
           <a:xfrm>
-            <a:off x="9756648" y="1345692"/>
-            <a:ext cx="2121408" cy="365760"/>
+            <a:off x="9692640" y="1452202"/>
+            <a:ext cx="2148840" cy="289390"/>
           </a:xfrm>
           <a:prstGeom prst="rect">
             <a:avLst/>
@@ -4322,7 +4322,7 @@
         </p:nvSpPr>
         <p:spPr>
           <a:xfrm>
-            <a:off x="0" y="1769110"/>
+            <a:off x="0" y="1817539"/>
             <a:ext cx="12188952" cy="6350"/>
           </a:xfrm>
           <a:prstGeom prst="rect">
@@ -4365,8 +4365,8 @@
         </p:nvSpPr>
         <p:spPr>
           <a:xfrm>
-            <a:off x="0" y="1775460"/>
-            <a:ext cx="12188952" cy="640080"/>
+            <a:off x="0" y="1823889"/>
+            <a:ext cx="12188952" cy="627718"/>
           </a:xfrm>
           <a:prstGeom prst="rect">
             <a:avLst/>
@@ -4408,8 +4408,8 @@
         </p:nvSpPr>
         <p:spPr>
           <a:xfrm>
-            <a:off x="256032" y="1812036"/>
-            <a:ext cx="4773168" cy="146304"/>
+            <a:off x="292608" y="1878753"/>
+            <a:ext cx="4562856" cy="164592"/>
           </a:xfrm>
           <a:prstGeom prst="rect">
             <a:avLst/>
@@ -4443,8 +4443,8 @@
         </p:nvSpPr>
         <p:spPr>
           <a:xfrm>
-            <a:off x="256032" y="1976628"/>
-            <a:ext cx="4773168" cy="420624"/>
+            <a:off x="292608" y="2079921"/>
+            <a:ext cx="4562856" cy="316822"/>
           </a:xfrm>
           <a:prstGeom prst="rect">
             <a:avLst/>
@@ -4478,8 +4478,8 @@
         </p:nvSpPr>
         <p:spPr>
           <a:xfrm>
-            <a:off x="5120640" y="1821180"/>
-            <a:ext cx="2194560" cy="548640"/>
+            <a:off x="4956048" y="1878753"/>
+            <a:ext cx="2221992" cy="517990"/>
           </a:xfrm>
           <a:prstGeom prst="rect">
             <a:avLst/>
@@ -4521,8 +4521,8 @@
         </p:nvSpPr>
         <p:spPr>
           <a:xfrm>
-            <a:off x="5184648" y="1848612"/>
-            <a:ext cx="2194560" cy="128016"/>
+            <a:off x="5029200" y="1915329"/>
+            <a:ext cx="2221992" cy="137160"/>
           </a:xfrm>
           <a:prstGeom prst="rect">
             <a:avLst/>
@@ -4556,8 +4556,8 @@
         </p:nvSpPr>
         <p:spPr>
           <a:xfrm>
-            <a:off x="5184648" y="1985772"/>
-            <a:ext cx="2121408" cy="365760"/>
+            <a:off x="5029200" y="2079921"/>
+            <a:ext cx="2148840" cy="289390"/>
           </a:xfrm>
           <a:prstGeom prst="rect">
             <a:avLst/>
@@ -4591,8 +4591,8 @@
         </p:nvSpPr>
         <p:spPr>
           <a:xfrm>
-            <a:off x="7406640" y="1821180"/>
-            <a:ext cx="2194560" cy="548640"/>
+            <a:off x="7287768" y="1878753"/>
+            <a:ext cx="2221992" cy="517990"/>
           </a:xfrm>
           <a:prstGeom prst="rect">
             <a:avLst/>
@@ -4634,8 +4634,8 @@
         </p:nvSpPr>
         <p:spPr>
           <a:xfrm>
-            <a:off x="7470648" y="1848612"/>
-            <a:ext cx="2194560" cy="128016"/>
+            <a:off x="7360920" y="1915329"/>
+            <a:ext cx="2221992" cy="137160"/>
           </a:xfrm>
           <a:prstGeom prst="rect">
             <a:avLst/>
@@ -4669,8 +4669,8 @@
         </p:nvSpPr>
         <p:spPr>
           <a:xfrm>
-            <a:off x="7470648" y="1985772"/>
-            <a:ext cx="2121408" cy="365760"/>
+            <a:off x="7360920" y="2079921"/>
+            <a:ext cx="2148840" cy="289390"/>
           </a:xfrm>
           <a:prstGeom prst="rect">
             <a:avLst/>
@@ -4704,8 +4704,8 @@
         </p:nvSpPr>
         <p:spPr>
           <a:xfrm>
-            <a:off x="9692640" y="1821180"/>
-            <a:ext cx="2194560" cy="548640"/>
+            <a:off x="9619488" y="1878753"/>
+            <a:ext cx="2221992" cy="517990"/>
           </a:xfrm>
           <a:prstGeom prst="rect">
             <a:avLst/>
@@ -4747,8 +4747,8 @@
         </p:nvSpPr>
         <p:spPr>
           <a:xfrm>
-            <a:off x="9756648" y="1848612"/>
-            <a:ext cx="2194560" cy="128016"/>
+            <a:off x="9692640" y="1915329"/>
+            <a:ext cx="2221992" cy="137160"/>
           </a:xfrm>
           <a:prstGeom prst="rect">
             <a:avLst/>
@@ -4782,8 +4782,8 @@
         </p:nvSpPr>
         <p:spPr>
           <a:xfrm>
-            <a:off x="9756648" y="1985772"/>
-            <a:ext cx="2121408" cy="365760"/>
+            <a:off x="9692640" y="2079921"/>
+            <a:ext cx="2148840" cy="289390"/>
           </a:xfrm>
           <a:prstGeom prst="rect">
             <a:avLst/>
@@ -4817,7 +4817,7 @@
         </p:nvSpPr>
         <p:spPr>
           <a:xfrm>
-            <a:off x="0" y="2409190"/>
+            <a:off x="0" y="2445257"/>
             <a:ext cx="12188952" cy="6350"/>
           </a:xfrm>
           <a:prstGeom prst="rect">
@@ -4860,8 +4860,8 @@
         </p:nvSpPr>
         <p:spPr>
           <a:xfrm>
-            <a:off x="0" y="2461260"/>
-            <a:ext cx="12188952" cy="201168"/>
+            <a:off x="0" y="2506471"/>
+            <a:ext cx="12188952" cy="237744"/>
           </a:xfrm>
           <a:prstGeom prst="rect">
             <a:avLst/>
@@ -4903,23 +4903,23 @@
         </p:nvSpPr>
         <p:spPr>
           <a:xfrm>
-            <a:off x="256032" y="2488692"/>
-            <a:ext cx="4818888" cy="201168"/>
-          </a:xfrm>
-          <a:prstGeom prst="rect">
-            <a:avLst/>
-          </a:prstGeom>
-          <a:noFill/>
-        </p:spPr>
-        <p:txBody>
-          <a:bodyPr wrap="square">
-            <a:spAutoFit/>
-          </a:bodyPr>
-          <a:lstStyle/>
-          <a:p>
-            <a:pPr algn="l"/>
-            <a:r>
-              <a:rPr sz="800" b="1" i="0">
+            <a:off x="292608" y="2543047"/>
+            <a:ext cx="4608576" cy="201168"/>
+          </a:xfrm>
+          <a:prstGeom prst="rect">
+            <a:avLst/>
+          </a:prstGeom>
+          <a:noFill/>
+        </p:spPr>
+        <p:txBody>
+          <a:bodyPr wrap="square">
+            <a:spAutoFit/>
+          </a:bodyPr>
+          <a:lstStyle/>
+          <a:p>
+            <a:pPr algn="l"/>
+            <a:r>
+              <a:rPr sz="900" b="1" i="0">
                 <a:solidFill>
                   <a:srgbClr val="FFFFFF"/>
                 </a:solidFill>
@@ -4938,8 +4938,8 @@
         </p:nvSpPr>
         <p:spPr>
           <a:xfrm>
-            <a:off x="0" y="2662428"/>
-            <a:ext cx="12188952" cy="640080"/>
+            <a:off x="0" y="2744215"/>
+            <a:ext cx="12188952" cy="627718"/>
           </a:xfrm>
           <a:prstGeom prst="rect">
             <a:avLst/>
@@ -4981,8 +4981,8 @@
         </p:nvSpPr>
         <p:spPr>
           <a:xfrm>
-            <a:off x="256032" y="2699004"/>
-            <a:ext cx="4773168" cy="146304"/>
+            <a:off x="292608" y="2799079"/>
+            <a:ext cx="4562856" cy="164592"/>
           </a:xfrm>
           <a:prstGeom prst="rect">
             <a:avLst/>
@@ -5016,8 +5016,8 @@
         </p:nvSpPr>
         <p:spPr>
           <a:xfrm>
-            <a:off x="256032" y="2863596"/>
-            <a:ext cx="4773168" cy="420624"/>
+            <a:off x="292608" y="3000247"/>
+            <a:ext cx="4562856" cy="316822"/>
           </a:xfrm>
           <a:prstGeom prst="rect">
             <a:avLst/>
@@ -5051,8 +5051,8 @@
         </p:nvSpPr>
         <p:spPr>
           <a:xfrm>
-            <a:off x="5120640" y="2708148"/>
-            <a:ext cx="2194560" cy="548640"/>
+            <a:off x="4956048" y="2799079"/>
+            <a:ext cx="2221992" cy="517990"/>
           </a:xfrm>
           <a:prstGeom prst="rect">
             <a:avLst/>
@@ -5094,8 +5094,8 @@
         </p:nvSpPr>
         <p:spPr>
           <a:xfrm>
-            <a:off x="5184648" y="2735580"/>
-            <a:ext cx="2194560" cy="128016"/>
+            <a:off x="5029200" y="2835655"/>
+            <a:ext cx="2221992" cy="137160"/>
           </a:xfrm>
           <a:prstGeom prst="rect">
             <a:avLst/>
@@ -5129,8 +5129,8 @@
         </p:nvSpPr>
         <p:spPr>
           <a:xfrm>
-            <a:off x="5184648" y="2872740"/>
-            <a:ext cx="2121408" cy="365760"/>
+            <a:off x="5029200" y="3000247"/>
+            <a:ext cx="2148840" cy="289390"/>
           </a:xfrm>
           <a:prstGeom prst="rect">
             <a:avLst/>
@@ -5164,8 +5164,8 @@
         </p:nvSpPr>
         <p:spPr>
           <a:xfrm>
-            <a:off x="7406640" y="2708148"/>
-            <a:ext cx="2194560" cy="548640"/>
+            <a:off x="7287768" y="2799079"/>
+            <a:ext cx="2221992" cy="517990"/>
           </a:xfrm>
           <a:prstGeom prst="rect">
             <a:avLst/>
@@ -5207,8 +5207,8 @@
         </p:nvSpPr>
         <p:spPr>
           <a:xfrm>
-            <a:off x="7470648" y="2735580"/>
-            <a:ext cx="2194560" cy="128016"/>
+            <a:off x="7360920" y="2835655"/>
+            <a:ext cx="2221992" cy="137160"/>
           </a:xfrm>
           <a:prstGeom prst="rect">
             <a:avLst/>
@@ -5242,8 +5242,8 @@
         </p:nvSpPr>
         <p:spPr>
           <a:xfrm>
-            <a:off x="7470648" y="2872740"/>
-            <a:ext cx="2121408" cy="365760"/>
+            <a:off x="7360920" y="3000247"/>
+            <a:ext cx="2148840" cy="289390"/>
           </a:xfrm>
           <a:prstGeom prst="rect">
             <a:avLst/>
@@ -5277,8 +5277,8 @@
         </p:nvSpPr>
         <p:spPr>
           <a:xfrm>
-            <a:off x="9692640" y="2708148"/>
-            <a:ext cx="2194560" cy="548640"/>
+            <a:off x="9619488" y="2799079"/>
+            <a:ext cx="2221992" cy="517990"/>
           </a:xfrm>
           <a:prstGeom prst="rect">
             <a:avLst/>
@@ -5320,8 +5320,8 @@
         </p:nvSpPr>
         <p:spPr>
           <a:xfrm>
-            <a:off x="9756648" y="2735580"/>
-            <a:ext cx="2194560" cy="128016"/>
+            <a:off x="9692640" y="2835655"/>
+            <a:ext cx="2221992" cy="137160"/>
           </a:xfrm>
           <a:prstGeom prst="rect">
             <a:avLst/>
@@ -5355,8 +5355,8 @@
         </p:nvSpPr>
         <p:spPr>
           <a:xfrm>
-            <a:off x="9756648" y="2872740"/>
-            <a:ext cx="2121408" cy="365760"/>
+            <a:off x="9692640" y="3000247"/>
+            <a:ext cx="2148840" cy="289390"/>
           </a:xfrm>
           <a:prstGeom prst="rect">
             <a:avLst/>
@@ -5390,7 +5390,7 @@
         </p:nvSpPr>
         <p:spPr>
           <a:xfrm>
-            <a:off x="0" y="3296158"/>
+            <a:off x="0" y="3365584"/>
             <a:ext cx="12188952" cy="6350"/>
           </a:xfrm>
           <a:prstGeom prst="rect">
@@ -5433,8 +5433,8 @@
         </p:nvSpPr>
         <p:spPr>
           <a:xfrm>
-            <a:off x="0" y="3302508"/>
-            <a:ext cx="12188952" cy="640080"/>
+            <a:off x="0" y="3371934"/>
+            <a:ext cx="12188952" cy="627718"/>
           </a:xfrm>
           <a:prstGeom prst="rect">
             <a:avLst/>
@@ -5476,8 +5476,8 @@
         </p:nvSpPr>
         <p:spPr>
           <a:xfrm>
-            <a:off x="256032" y="3339084"/>
-            <a:ext cx="4773168" cy="146304"/>
+            <a:off x="292608" y="3426798"/>
+            <a:ext cx="4562856" cy="164592"/>
           </a:xfrm>
           <a:prstGeom prst="rect">
             <a:avLst/>
@@ -5511,8 +5511,8 @@
         </p:nvSpPr>
         <p:spPr>
           <a:xfrm>
-            <a:off x="256032" y="3503676"/>
-            <a:ext cx="4773168" cy="420624"/>
+            <a:off x="292608" y="3627966"/>
+            <a:ext cx="4562856" cy="316822"/>
           </a:xfrm>
           <a:prstGeom prst="rect">
             <a:avLst/>
@@ -5546,8 +5546,8 @@
         </p:nvSpPr>
         <p:spPr>
           <a:xfrm>
-            <a:off x="5120640" y="3348228"/>
-            <a:ext cx="2194560" cy="548640"/>
+            <a:off x="4956048" y="3426798"/>
+            <a:ext cx="2221992" cy="517990"/>
           </a:xfrm>
           <a:prstGeom prst="rect">
             <a:avLst/>
@@ -5589,8 +5589,8 @@
         </p:nvSpPr>
         <p:spPr>
           <a:xfrm>
-            <a:off x="5184648" y="3375660"/>
-            <a:ext cx="2194560" cy="128016"/>
+            <a:off x="5029200" y="3463374"/>
+            <a:ext cx="2221992" cy="137160"/>
           </a:xfrm>
           <a:prstGeom prst="rect">
             <a:avLst/>
@@ -5624,8 +5624,8 @@
         </p:nvSpPr>
         <p:spPr>
           <a:xfrm>
-            <a:off x="5184648" y="3512820"/>
-            <a:ext cx="2121408" cy="365760"/>
+            <a:off x="5029200" y="3627966"/>
+            <a:ext cx="2148840" cy="289390"/>
           </a:xfrm>
           <a:prstGeom prst="rect">
             <a:avLst/>
@@ -5659,8 +5659,8 @@
         </p:nvSpPr>
         <p:spPr>
           <a:xfrm>
-            <a:off x="7406640" y="3348228"/>
-            <a:ext cx="2194560" cy="548640"/>
+            <a:off x="7287768" y="3426798"/>
+            <a:ext cx="2221992" cy="517990"/>
           </a:xfrm>
           <a:prstGeom prst="rect">
             <a:avLst/>
@@ -5702,8 +5702,8 @@
         </p:nvSpPr>
         <p:spPr>
           <a:xfrm>
-            <a:off x="7470648" y="3375660"/>
-            <a:ext cx="2194560" cy="128016"/>
+            <a:off x="7360920" y="3463374"/>
+            <a:ext cx="2221992" cy="137160"/>
           </a:xfrm>
           <a:prstGeom prst="rect">
             <a:avLst/>
@@ -5737,8 +5737,8 @@
         </p:nvSpPr>
         <p:spPr>
           <a:xfrm>
-            <a:off x="7470648" y="3512820"/>
-            <a:ext cx="2121408" cy="365760"/>
+            <a:off x="7360920" y="3627966"/>
+            <a:ext cx="2148840" cy="289390"/>
           </a:xfrm>
           <a:prstGeom prst="rect">
             <a:avLst/>
@@ -5772,8 +5772,8 @@
         </p:nvSpPr>
         <p:spPr>
           <a:xfrm>
-            <a:off x="9692640" y="3348228"/>
-            <a:ext cx="2194560" cy="548640"/>
+            <a:off x="9619488" y="3426798"/>
+            <a:ext cx="2221992" cy="517990"/>
           </a:xfrm>
           <a:prstGeom prst="rect">
             <a:avLst/>
@@ -5815,8 +5815,8 @@
         </p:nvSpPr>
         <p:spPr>
           <a:xfrm>
-            <a:off x="9756648" y="3375660"/>
-            <a:ext cx="2194560" cy="128016"/>
+            <a:off x="9692640" y="3463374"/>
+            <a:ext cx="2221992" cy="137160"/>
           </a:xfrm>
           <a:prstGeom prst="rect">
             <a:avLst/>
@@ -5850,8 +5850,8 @@
         </p:nvSpPr>
         <p:spPr>
           <a:xfrm>
-            <a:off x="9756648" y="3512820"/>
-            <a:ext cx="2121408" cy="365760"/>
+            <a:off x="9692640" y="3627966"/>
+            <a:ext cx="2148840" cy="289390"/>
           </a:xfrm>
           <a:prstGeom prst="rect">
             <a:avLst/>
@@ -5885,7 +5885,7 @@
         </p:nvSpPr>
         <p:spPr>
           <a:xfrm>
-            <a:off x="0" y="3936238"/>
+            <a:off x="0" y="3993303"/>
             <a:ext cx="12188952" cy="6350"/>
           </a:xfrm>
           <a:prstGeom prst="rect">
@@ -5928,8 +5928,8 @@
         </p:nvSpPr>
         <p:spPr>
           <a:xfrm>
-            <a:off x="0" y="3988308"/>
-            <a:ext cx="12188952" cy="201168"/>
+            <a:off x="0" y="4054517"/>
+            <a:ext cx="12188952" cy="237744"/>
           </a:xfrm>
           <a:prstGeom prst="rect">
             <a:avLst/>
@@ -5971,23 +5971,23 @@
         </p:nvSpPr>
         <p:spPr>
           <a:xfrm>
-            <a:off x="256032" y="4015740"/>
-            <a:ext cx="4818888" cy="201168"/>
-          </a:xfrm>
-          <a:prstGeom prst="rect">
-            <a:avLst/>
-          </a:prstGeom>
-          <a:noFill/>
-        </p:spPr>
-        <p:txBody>
-          <a:bodyPr wrap="square">
-            <a:spAutoFit/>
-          </a:bodyPr>
-          <a:lstStyle/>
-          <a:p>
-            <a:pPr algn="l"/>
-            <a:r>
-              <a:rPr sz="800" b="1" i="0">
+            <a:off x="292608" y="4091093"/>
+            <a:ext cx="4608576" cy="201168"/>
+          </a:xfrm>
+          <a:prstGeom prst="rect">
+            <a:avLst/>
+          </a:prstGeom>
+          <a:noFill/>
+        </p:spPr>
+        <p:txBody>
+          <a:bodyPr wrap="square">
+            <a:spAutoFit/>
+          </a:bodyPr>
+          <a:lstStyle/>
+          <a:p>
+            <a:pPr algn="l"/>
+            <a:r>
+              <a:rPr sz="900" b="1" i="0">
                 <a:solidFill>
                   <a:srgbClr val="FFFFFF"/>
                 </a:solidFill>
@@ -6006,8 +6006,8 @@
         </p:nvSpPr>
         <p:spPr>
           <a:xfrm>
-            <a:off x="0" y="4189476"/>
-            <a:ext cx="12188952" cy="640080"/>
+            <a:off x="0" y="4292261"/>
+            <a:ext cx="12188952" cy="627718"/>
           </a:xfrm>
           <a:prstGeom prst="rect">
             <a:avLst/>
@@ -6049,8 +6049,8 @@
         </p:nvSpPr>
         <p:spPr>
           <a:xfrm>
-            <a:off x="256032" y="4226052"/>
-            <a:ext cx="4773168" cy="146304"/>
+            <a:off x="292608" y="4347125"/>
+            <a:ext cx="4562856" cy="164592"/>
           </a:xfrm>
           <a:prstGeom prst="rect">
             <a:avLst/>
@@ -6084,8 +6084,8 @@
         </p:nvSpPr>
         <p:spPr>
           <a:xfrm>
-            <a:off x="256032" y="4390644"/>
-            <a:ext cx="4773168" cy="420624"/>
+            <a:off x="292608" y="4548293"/>
+            <a:ext cx="4562856" cy="316822"/>
           </a:xfrm>
           <a:prstGeom prst="rect">
             <a:avLst/>
@@ -6119,8 +6119,8 @@
         </p:nvSpPr>
         <p:spPr>
           <a:xfrm>
-            <a:off x="5120640" y="4235196"/>
-            <a:ext cx="2194560" cy="548640"/>
+            <a:off x="4956048" y="4347125"/>
+            <a:ext cx="2221992" cy="517990"/>
           </a:xfrm>
           <a:prstGeom prst="rect">
             <a:avLst/>
@@ -6162,8 +6162,8 @@
         </p:nvSpPr>
         <p:spPr>
           <a:xfrm>
-            <a:off x="5184648" y="4262628"/>
-            <a:ext cx="2194560" cy="128016"/>
+            <a:off x="5029200" y="4383701"/>
+            <a:ext cx="2221992" cy="137160"/>
           </a:xfrm>
           <a:prstGeom prst="rect">
             <a:avLst/>
@@ -6197,8 +6197,8 @@
         </p:nvSpPr>
         <p:spPr>
           <a:xfrm>
-            <a:off x="5184648" y="4399788"/>
-            <a:ext cx="2121408" cy="365760"/>
+            <a:off x="5029200" y="4548293"/>
+            <a:ext cx="2148840" cy="289390"/>
           </a:xfrm>
           <a:prstGeom prst="rect">
             <a:avLst/>
@@ -6232,8 +6232,8 @@
         </p:nvSpPr>
         <p:spPr>
           <a:xfrm>
-            <a:off x="7406640" y="4235196"/>
-            <a:ext cx="2194560" cy="548640"/>
+            <a:off x="7287768" y="4347125"/>
+            <a:ext cx="2221992" cy="517990"/>
           </a:xfrm>
           <a:prstGeom prst="rect">
             <a:avLst/>
@@ -6275,8 +6275,8 @@
         </p:nvSpPr>
         <p:spPr>
           <a:xfrm>
-            <a:off x="7470648" y="4262628"/>
-            <a:ext cx="2194560" cy="128016"/>
+            <a:off x="7360920" y="4383701"/>
+            <a:ext cx="2221992" cy="137160"/>
           </a:xfrm>
           <a:prstGeom prst="rect">
             <a:avLst/>
@@ -6310,8 +6310,8 @@
         </p:nvSpPr>
         <p:spPr>
           <a:xfrm>
-            <a:off x="7470648" y="4399788"/>
-            <a:ext cx="2121408" cy="365760"/>
+            <a:off x="7360920" y="4548293"/>
+            <a:ext cx="2148840" cy="289390"/>
           </a:xfrm>
           <a:prstGeom prst="rect">
             <a:avLst/>
@@ -6345,8 +6345,8 @@
         </p:nvSpPr>
         <p:spPr>
           <a:xfrm>
-            <a:off x="9692640" y="4235196"/>
-            <a:ext cx="2194560" cy="548640"/>
+            <a:off x="9619488" y="4347125"/>
+            <a:ext cx="2221992" cy="517990"/>
           </a:xfrm>
           <a:prstGeom prst="rect">
             <a:avLst/>
@@ -6388,8 +6388,8 @@
         </p:nvSpPr>
         <p:spPr>
           <a:xfrm>
-            <a:off x="9756648" y="4262628"/>
-            <a:ext cx="2194560" cy="128016"/>
+            <a:off x="9692640" y="4383701"/>
+            <a:ext cx="2221992" cy="137160"/>
           </a:xfrm>
           <a:prstGeom prst="rect">
             <a:avLst/>
@@ -6423,8 +6423,8 @@
         </p:nvSpPr>
         <p:spPr>
           <a:xfrm>
-            <a:off x="9756648" y="4399788"/>
-            <a:ext cx="2121408" cy="365760"/>
+            <a:off x="9692640" y="4548293"/>
+            <a:ext cx="2148840" cy="289390"/>
           </a:xfrm>
           <a:prstGeom prst="rect">
             <a:avLst/>
@@ -6458,7 +6458,7 @@
         </p:nvSpPr>
         <p:spPr>
           <a:xfrm>
-            <a:off x="0" y="4823206"/>
+            <a:off x="0" y="4913629"/>
             <a:ext cx="12188952" cy="6350"/>
           </a:xfrm>
           <a:prstGeom prst="rect">
@@ -6501,8 +6501,8 @@
         </p:nvSpPr>
         <p:spPr>
           <a:xfrm>
-            <a:off x="0" y="4829556"/>
-            <a:ext cx="12188952" cy="640080"/>
+            <a:off x="0" y="4919979"/>
+            <a:ext cx="12188952" cy="627718"/>
           </a:xfrm>
           <a:prstGeom prst="rect">
             <a:avLst/>
@@ -6544,8 +6544,8 @@
         </p:nvSpPr>
         <p:spPr>
           <a:xfrm>
-            <a:off x="256032" y="4866132"/>
-            <a:ext cx="4773168" cy="146304"/>
+            <a:off x="292608" y="4974843"/>
+            <a:ext cx="4562856" cy="164592"/>
           </a:xfrm>
           <a:prstGeom prst="rect">
             <a:avLst/>
@@ -6579,8 +6579,8 @@
         </p:nvSpPr>
         <p:spPr>
           <a:xfrm>
-            <a:off x="256032" y="5030724"/>
-            <a:ext cx="4773168" cy="420624"/>
+            <a:off x="292608" y="5176011"/>
+            <a:ext cx="4562856" cy="316822"/>
           </a:xfrm>
           <a:prstGeom prst="rect">
             <a:avLst/>
@@ -6614,8 +6614,8 @@
         </p:nvSpPr>
         <p:spPr>
           <a:xfrm>
-            <a:off x="5120640" y="4875276"/>
-            <a:ext cx="2194560" cy="548640"/>
+            <a:off x="4956048" y="4974843"/>
+            <a:ext cx="2221992" cy="517990"/>
           </a:xfrm>
           <a:prstGeom prst="rect">
             <a:avLst/>
@@ -6657,8 +6657,8 @@
         </p:nvSpPr>
         <p:spPr>
           <a:xfrm>
-            <a:off x="5184648" y="4902708"/>
-            <a:ext cx="2194560" cy="128016"/>
+            <a:off x="5029200" y="5011419"/>
+            <a:ext cx="2221992" cy="137160"/>
           </a:xfrm>
           <a:prstGeom prst="rect">
             <a:avLst/>
@@ -6692,8 +6692,8 @@
         </p:nvSpPr>
         <p:spPr>
           <a:xfrm>
-            <a:off x="5184648" y="5039868"/>
-            <a:ext cx="2121408" cy="365760"/>
+            <a:off x="5029200" y="5176011"/>
+            <a:ext cx="2148840" cy="289390"/>
           </a:xfrm>
           <a:prstGeom prst="rect">
             <a:avLst/>
@@ -6727,8 +6727,8 @@
         </p:nvSpPr>
         <p:spPr>
           <a:xfrm>
-            <a:off x="7406640" y="4875276"/>
-            <a:ext cx="2194560" cy="548640"/>
+            <a:off x="7287768" y="4974843"/>
+            <a:ext cx="2221992" cy="517990"/>
           </a:xfrm>
           <a:prstGeom prst="rect">
             <a:avLst/>
@@ -6770,8 +6770,8 @@
         </p:nvSpPr>
         <p:spPr>
           <a:xfrm>
-            <a:off x="7470648" y="4902708"/>
-            <a:ext cx="2194560" cy="128016"/>
+            <a:off x="7360920" y="5011419"/>
+            <a:ext cx="2221992" cy="137160"/>
           </a:xfrm>
           <a:prstGeom prst="rect">
             <a:avLst/>
@@ -6805,8 +6805,8 @@
         </p:nvSpPr>
         <p:spPr>
           <a:xfrm>
-            <a:off x="7470648" y="5039868"/>
-            <a:ext cx="2121408" cy="365760"/>
+            <a:off x="7360920" y="5176011"/>
+            <a:ext cx="2148840" cy="289390"/>
           </a:xfrm>
           <a:prstGeom prst="rect">
             <a:avLst/>
@@ -6840,8 +6840,8 @@
         </p:nvSpPr>
         <p:spPr>
           <a:xfrm>
-            <a:off x="9692640" y="4875276"/>
-            <a:ext cx="2194560" cy="548640"/>
+            <a:off x="9619488" y="4974843"/>
+            <a:ext cx="2221992" cy="517990"/>
           </a:xfrm>
           <a:prstGeom prst="rect">
             <a:avLst/>
@@ -6883,8 +6883,8 @@
         </p:nvSpPr>
         <p:spPr>
           <a:xfrm>
-            <a:off x="9756648" y="4902708"/>
-            <a:ext cx="2194560" cy="128016"/>
+            <a:off x="9692640" y="5011419"/>
+            <a:ext cx="2221992" cy="137160"/>
           </a:xfrm>
           <a:prstGeom prst="rect">
             <a:avLst/>
@@ -6918,8 +6918,8 @@
         </p:nvSpPr>
         <p:spPr>
           <a:xfrm>
-            <a:off x="9756648" y="5039868"/>
-            <a:ext cx="2121408" cy="365760"/>
+            <a:off x="9692640" y="5176011"/>
+            <a:ext cx="2148840" cy="289390"/>
           </a:xfrm>
           <a:prstGeom prst="rect">
             <a:avLst/>
@@ -6953,7 +6953,7 @@
         </p:nvSpPr>
         <p:spPr>
           <a:xfrm>
-            <a:off x="0" y="5463286"/>
+            <a:off x="0" y="5541348"/>
             <a:ext cx="12188952" cy="6350"/>
           </a:xfrm>
           <a:prstGeom prst="rect">
@@ -6996,8 +6996,8 @@
         </p:nvSpPr>
         <p:spPr>
           <a:xfrm>
-            <a:off x="0" y="5469636"/>
-            <a:ext cx="12188952" cy="640080"/>
+            <a:off x="0" y="5547698"/>
+            <a:ext cx="12188952" cy="627718"/>
           </a:xfrm>
           <a:prstGeom prst="rect">
             <a:avLst/>
@@ -7039,8 +7039,8 @@
         </p:nvSpPr>
         <p:spPr>
           <a:xfrm>
-            <a:off x="256032" y="5506212"/>
-            <a:ext cx="4773168" cy="146304"/>
+            <a:off x="292608" y="5602562"/>
+            <a:ext cx="4562856" cy="164592"/>
           </a:xfrm>
           <a:prstGeom prst="rect">
             <a:avLst/>
@@ -7074,8 +7074,8 @@
         </p:nvSpPr>
         <p:spPr>
           <a:xfrm>
-            <a:off x="256032" y="5670804"/>
-            <a:ext cx="4773168" cy="420624"/>
+            <a:off x="292608" y="5803730"/>
+            <a:ext cx="4562856" cy="316822"/>
           </a:xfrm>
           <a:prstGeom prst="rect">
             <a:avLst/>
@@ -7109,8 +7109,8 @@
         </p:nvSpPr>
         <p:spPr>
           <a:xfrm>
-            <a:off x="5120640" y="5515356"/>
-            <a:ext cx="2194560" cy="548640"/>
+            <a:off x="4956048" y="5602562"/>
+            <a:ext cx="2221992" cy="517990"/>
           </a:xfrm>
           <a:prstGeom prst="rect">
             <a:avLst/>
@@ -7152,8 +7152,8 @@
         </p:nvSpPr>
         <p:spPr>
           <a:xfrm>
-            <a:off x="5184648" y="5542788"/>
-            <a:ext cx="2194560" cy="128016"/>
+            <a:off x="5029200" y="5639138"/>
+            <a:ext cx="2221992" cy="137160"/>
           </a:xfrm>
           <a:prstGeom prst="rect">
             <a:avLst/>
@@ -7187,8 +7187,8 @@
         </p:nvSpPr>
         <p:spPr>
           <a:xfrm>
-            <a:off x="5184648" y="5679948"/>
-            <a:ext cx="2121408" cy="365760"/>
+            <a:off x="5029200" y="5803730"/>
+            <a:ext cx="2148840" cy="289390"/>
           </a:xfrm>
           <a:prstGeom prst="rect">
             <a:avLst/>
@@ -7222,8 +7222,8 @@
         </p:nvSpPr>
         <p:spPr>
           <a:xfrm>
-            <a:off x="7406640" y="5515356"/>
-            <a:ext cx="2194560" cy="548640"/>
+            <a:off x="7287768" y="5602562"/>
+            <a:ext cx="2221992" cy="517990"/>
           </a:xfrm>
           <a:prstGeom prst="rect">
             <a:avLst/>
@@ -7265,8 +7265,8 @@
         </p:nvSpPr>
         <p:spPr>
           <a:xfrm>
-            <a:off x="7470648" y="5542788"/>
-            <a:ext cx="2194560" cy="128016"/>
+            <a:off x="7360920" y="5639138"/>
+            <a:ext cx="2221992" cy="137160"/>
           </a:xfrm>
           <a:prstGeom prst="rect">
             <a:avLst/>
@@ -7300,8 +7300,8 @@
         </p:nvSpPr>
         <p:spPr>
           <a:xfrm>
-            <a:off x="7470648" y="5679948"/>
-            <a:ext cx="2121408" cy="365760"/>
+            <a:off x="7360920" y="5803730"/>
+            <a:ext cx="2148840" cy="289390"/>
           </a:xfrm>
           <a:prstGeom prst="rect">
             <a:avLst/>
@@ -7335,8 +7335,8 @@
         </p:nvSpPr>
         <p:spPr>
           <a:xfrm>
-            <a:off x="9692640" y="5515356"/>
-            <a:ext cx="2194560" cy="548640"/>
+            <a:off x="9619488" y="5602562"/>
+            <a:ext cx="2221992" cy="517990"/>
           </a:xfrm>
           <a:prstGeom prst="rect">
             <a:avLst/>
@@ -7378,8 +7378,8 @@
         </p:nvSpPr>
         <p:spPr>
           <a:xfrm>
-            <a:off x="9756648" y="5542788"/>
-            <a:ext cx="2194560" cy="128016"/>
+            <a:off x="9692640" y="5639138"/>
+            <a:ext cx="2221992" cy="137160"/>
           </a:xfrm>
           <a:prstGeom prst="rect">
             <a:avLst/>
@@ -7413,8 +7413,8 @@
         </p:nvSpPr>
         <p:spPr>
           <a:xfrm>
-            <a:off x="9756648" y="5679948"/>
-            <a:ext cx="2121408" cy="365760"/>
+            <a:off x="9692640" y="5803730"/>
+            <a:ext cx="2148840" cy="289390"/>
           </a:xfrm>
           <a:prstGeom prst="rect">
             <a:avLst/>
@@ -7448,7 +7448,7 @@
         </p:nvSpPr>
         <p:spPr>
           <a:xfrm>
-            <a:off x="0" y="6103366"/>
+            <a:off x="0" y="6169067"/>
             <a:ext cx="12188952" cy="6350"/>
           </a:xfrm>
           <a:prstGeom prst="rect">
@@ -7491,8 +7491,8 @@
         </p:nvSpPr>
         <p:spPr>
           <a:xfrm>
-            <a:off x="0" y="6109716"/>
-            <a:ext cx="12188952" cy="640080"/>
+            <a:off x="0" y="6175417"/>
+            <a:ext cx="12188952" cy="627718"/>
           </a:xfrm>
           <a:prstGeom prst="rect">
             <a:avLst/>
@@ -7534,8 +7534,8 @@
         </p:nvSpPr>
         <p:spPr>
           <a:xfrm>
-            <a:off x="256032" y="6146292"/>
-            <a:ext cx="4773168" cy="146304"/>
+            <a:off x="292608" y="6230281"/>
+            <a:ext cx="4562856" cy="164592"/>
           </a:xfrm>
           <a:prstGeom prst="rect">
             <a:avLst/>
@@ -7569,8 +7569,8 @@
         </p:nvSpPr>
         <p:spPr>
           <a:xfrm>
-            <a:off x="256032" y="6310884"/>
-            <a:ext cx="4773168" cy="420624"/>
+            <a:off x="292608" y="6431449"/>
+            <a:ext cx="4562856" cy="316822"/>
           </a:xfrm>
           <a:prstGeom prst="rect">
             <a:avLst/>
@@ -7604,8 +7604,8 @@
         </p:nvSpPr>
         <p:spPr>
           <a:xfrm>
-            <a:off x="5120640" y="6155436"/>
-            <a:ext cx="2194560" cy="548640"/>
+            <a:off x="4956048" y="6230281"/>
+            <a:ext cx="2221992" cy="517990"/>
           </a:xfrm>
           <a:prstGeom prst="rect">
             <a:avLst/>
@@ -7647,8 +7647,8 @@
         </p:nvSpPr>
         <p:spPr>
           <a:xfrm>
-            <a:off x="5184648" y="6182868"/>
-            <a:ext cx="2194560" cy="128016"/>
+            <a:off x="5029200" y="6266857"/>
+            <a:ext cx="2221992" cy="137160"/>
           </a:xfrm>
           <a:prstGeom prst="rect">
             <a:avLst/>
@@ -7682,8 +7682,8 @@
         </p:nvSpPr>
         <p:spPr>
           <a:xfrm>
-            <a:off x="5184648" y="6320028"/>
-            <a:ext cx="2121408" cy="365760"/>
+            <a:off x="5029200" y="6431449"/>
+            <a:ext cx="2148840" cy="289390"/>
           </a:xfrm>
           <a:prstGeom prst="rect">
             <a:avLst/>
@@ -7717,8 +7717,8 @@
         </p:nvSpPr>
         <p:spPr>
           <a:xfrm>
-            <a:off x="7406640" y="6155436"/>
-            <a:ext cx="2194560" cy="548640"/>
+            <a:off x="7287768" y="6230281"/>
+            <a:ext cx="2221992" cy="517990"/>
           </a:xfrm>
           <a:prstGeom prst="rect">
             <a:avLst/>
@@ -7760,8 +7760,8 @@
         </p:nvSpPr>
         <p:spPr>
           <a:xfrm>
-            <a:off x="7470648" y="6182868"/>
-            <a:ext cx="2194560" cy="128016"/>
+            <a:off x="7360920" y="6266857"/>
+            <a:ext cx="2221992" cy="137160"/>
           </a:xfrm>
           <a:prstGeom prst="rect">
             <a:avLst/>
@@ -7795,8 +7795,8 @@
         </p:nvSpPr>
         <p:spPr>
           <a:xfrm>
-            <a:off x="7470648" y="6320028"/>
-            <a:ext cx="2121408" cy="365760"/>
+            <a:off x="7360920" y="6431449"/>
+            <a:ext cx="2148840" cy="289390"/>
           </a:xfrm>
           <a:prstGeom prst="rect">
             <a:avLst/>
@@ -7830,8 +7830,8 @@
         </p:nvSpPr>
         <p:spPr>
           <a:xfrm>
-            <a:off x="9692640" y="6155436"/>
-            <a:ext cx="2194560" cy="548640"/>
+            <a:off x="9619488" y="6230281"/>
+            <a:ext cx="2221992" cy="517990"/>
           </a:xfrm>
           <a:prstGeom prst="rect">
             <a:avLst/>
@@ -7873,8 +7873,8 @@
         </p:nvSpPr>
         <p:spPr>
           <a:xfrm>
-            <a:off x="9756648" y="6182868"/>
-            <a:ext cx="2194560" cy="128016"/>
+            <a:off x="9692640" y="6266857"/>
+            <a:ext cx="2221992" cy="137160"/>
           </a:xfrm>
           <a:prstGeom prst="rect">
             <a:avLst/>
@@ -7908,8 +7908,8 @@
         </p:nvSpPr>
         <p:spPr>
           <a:xfrm>
-            <a:off x="9756648" y="6320028"/>
-            <a:ext cx="2121408" cy="365760"/>
+            <a:off x="9692640" y="6431449"/>
+            <a:ext cx="2148840" cy="289390"/>
           </a:xfrm>
           <a:prstGeom prst="rect">
             <a:avLst/>
@@ -7943,7 +7943,7 @@
         </p:nvSpPr>
         <p:spPr>
           <a:xfrm>
-            <a:off x="0" y="6743446"/>
+            <a:off x="0" y="6796786"/>
             <a:ext cx="12188952" cy="6350"/>
           </a:xfrm>
           <a:prstGeom prst="rect">
@@ -8048,7 +8048,7 @@
         <p:spPr>
           <a:xfrm>
             <a:off x="0" y="0"/>
-            <a:ext cx="12188952" cy="256032"/>
+            <a:ext cx="12188952" cy="292608"/>
           </a:xfrm>
           <a:prstGeom prst="rect">
             <a:avLst/>
@@ -8090,7 +8090,7 @@
         </p:nvSpPr>
         <p:spPr>
           <a:xfrm>
-            <a:off x="0" y="256032"/>
+            <a:off x="0" y="292608"/>
             <a:ext cx="12188952" cy="25400"/>
           </a:xfrm>
           <a:prstGeom prst="rect">
@@ -8133,23 +8133,23 @@
         </p:nvSpPr>
         <p:spPr>
           <a:xfrm>
-            <a:off x="256032" y="45720"/>
-            <a:ext cx="7315200" cy="256032"/>
-          </a:xfrm>
-          <a:prstGeom prst="rect">
-            <a:avLst/>
-          </a:prstGeom>
-          <a:noFill/>
-        </p:spPr>
-        <p:txBody>
-          <a:bodyPr wrap="square">
-            <a:spAutoFit/>
-          </a:bodyPr>
-          <a:lstStyle/>
-          <a:p>
-            <a:pPr algn="l"/>
-            <a:r>
-              <a:rPr sz="800" b="0" i="0">
+            <a:off x="292608" y="64008"/>
+            <a:ext cx="7315200" cy="292608"/>
+          </a:xfrm>
+          <a:prstGeom prst="rect">
+            <a:avLst/>
+          </a:prstGeom>
+          <a:noFill/>
+        </p:spPr>
+        <p:txBody>
+          <a:bodyPr wrap="square">
+            <a:spAutoFit/>
+          </a:bodyPr>
+          <a:lstStyle/>
+          <a:p>
+            <a:pPr algn="l"/>
+            <a:r>
+              <a:rPr sz="900" b="0" i="0">
                 <a:solidFill>
                   <a:srgbClr val="FFFFFF"/>
                 </a:solidFill>
@@ -8168,8 +8168,8 @@
         </p:nvSpPr>
         <p:spPr>
           <a:xfrm>
-            <a:off x="11548872" y="45720"/>
-            <a:ext cx="457200" cy="256032"/>
+            <a:off x="11548872" y="64008"/>
+            <a:ext cx="457200" cy="292608"/>
           </a:xfrm>
           <a:prstGeom prst="rect">
             <a:avLst/>
@@ -8203,8 +8203,8 @@
         </p:nvSpPr>
         <p:spPr>
           <a:xfrm>
-            <a:off x="0" y="294132"/>
-            <a:ext cx="12188952" cy="201168"/>
+            <a:off x="0" y="330708"/>
+            <a:ext cx="12188952" cy="237744"/>
           </a:xfrm>
           <a:prstGeom prst="rect">
             <a:avLst/>
@@ -8246,23 +8246,23 @@
         </p:nvSpPr>
         <p:spPr>
           <a:xfrm>
-            <a:off x="256032" y="321564"/>
-            <a:ext cx="4818888" cy="201168"/>
-          </a:xfrm>
-          <a:prstGeom prst="rect">
-            <a:avLst/>
-          </a:prstGeom>
-          <a:noFill/>
-        </p:spPr>
-        <p:txBody>
-          <a:bodyPr wrap="square">
-            <a:spAutoFit/>
-          </a:bodyPr>
-          <a:lstStyle/>
-          <a:p>
-            <a:pPr algn="l"/>
-            <a:r>
-              <a:rPr sz="800" b="1" i="0">
+            <a:off x="292608" y="367284"/>
+            <a:ext cx="4608576" cy="201168"/>
+          </a:xfrm>
+          <a:prstGeom prst="rect">
+            <a:avLst/>
+          </a:prstGeom>
+          <a:noFill/>
+        </p:spPr>
+        <p:txBody>
+          <a:bodyPr wrap="square">
+            <a:spAutoFit/>
+          </a:bodyPr>
+          <a:lstStyle/>
+          <a:p>
+            <a:pPr algn="l"/>
+            <a:r>
+              <a:rPr sz="900" b="1" i="0">
                 <a:solidFill>
                   <a:srgbClr val="FFFFFF"/>
                 </a:solidFill>
@@ -8281,8 +8281,8 @@
         </p:nvSpPr>
         <p:spPr>
           <a:xfrm>
-            <a:off x="0" y="495300"/>
-            <a:ext cx="12188952" cy="640080"/>
+            <a:off x="0" y="568452"/>
+            <a:ext cx="12188952" cy="848868"/>
           </a:xfrm>
           <a:prstGeom prst="rect">
             <a:avLst/>
@@ -8324,8 +8324,8 @@
         </p:nvSpPr>
         <p:spPr>
           <a:xfrm>
-            <a:off x="256032" y="531876"/>
-            <a:ext cx="4773168" cy="146304"/>
+            <a:off x="292608" y="623316"/>
+            <a:ext cx="4562856" cy="164592"/>
           </a:xfrm>
           <a:prstGeom prst="rect">
             <a:avLst/>
@@ -8359,23 +8359,23 @@
         </p:nvSpPr>
         <p:spPr>
           <a:xfrm>
-            <a:off x="256032" y="696468"/>
-            <a:ext cx="4773168" cy="420624"/>
-          </a:xfrm>
-          <a:prstGeom prst="rect">
-            <a:avLst/>
-          </a:prstGeom>
-          <a:noFill/>
-        </p:spPr>
-        <p:txBody>
-          <a:bodyPr wrap="square">
-            <a:spAutoFit/>
-          </a:bodyPr>
-          <a:lstStyle/>
-          <a:p>
-            <a:pPr algn="l"/>
-            <a:r>
-              <a:rPr sz="800" b="0" i="0">
+            <a:off x="292608" y="824484"/>
+            <a:ext cx="4562856" cy="537972"/>
+          </a:xfrm>
+          <a:prstGeom prst="rect">
+            <a:avLst/>
+          </a:prstGeom>
+          <a:noFill/>
+        </p:spPr>
+        <p:txBody>
+          <a:bodyPr wrap="square">
+            <a:spAutoFit/>
+          </a:bodyPr>
+          <a:lstStyle/>
+          <a:p>
+            <a:pPr algn="l"/>
+            <a:r>
+              <a:rPr sz="900" b="0" i="0">
                 <a:solidFill>
                   <a:srgbClr val="595959"/>
                 </a:solidFill>
@@ -8394,8 +8394,8 @@
         </p:nvSpPr>
         <p:spPr>
           <a:xfrm>
-            <a:off x="5120640" y="541020"/>
-            <a:ext cx="2194560" cy="548640"/>
+            <a:off x="4956048" y="623316"/>
+            <a:ext cx="2221992" cy="739140"/>
           </a:xfrm>
           <a:prstGeom prst="rect">
             <a:avLst/>
@@ -8437,8 +8437,8 @@
         </p:nvSpPr>
         <p:spPr>
           <a:xfrm>
-            <a:off x="5184648" y="568452"/>
-            <a:ext cx="2194560" cy="128016"/>
+            <a:off x="5029200" y="659892"/>
+            <a:ext cx="2221992" cy="137160"/>
           </a:xfrm>
           <a:prstGeom prst="rect">
             <a:avLst/>
@@ -8472,23 +8472,23 @@
         </p:nvSpPr>
         <p:spPr>
           <a:xfrm>
-            <a:off x="5184648" y="705612"/>
-            <a:ext cx="2121408" cy="365760"/>
-          </a:xfrm>
-          <a:prstGeom prst="rect">
-            <a:avLst/>
-          </a:prstGeom>
-          <a:noFill/>
-        </p:spPr>
-        <p:txBody>
-          <a:bodyPr wrap="square">
-            <a:spAutoFit/>
-          </a:bodyPr>
-          <a:lstStyle/>
-          <a:p>
-            <a:pPr algn="l"/>
-            <a:r>
-              <a:rPr sz="800" b="0" i="0">
+            <a:off x="5029200" y="824484"/>
+            <a:ext cx="2148840" cy="510540"/>
+          </a:xfrm>
+          <a:prstGeom prst="rect">
+            <a:avLst/>
+          </a:prstGeom>
+          <a:noFill/>
+        </p:spPr>
+        <p:txBody>
+          <a:bodyPr wrap="square">
+            <a:spAutoFit/>
+          </a:bodyPr>
+          <a:lstStyle/>
+          <a:p>
+            <a:pPr algn="l"/>
+            <a:r>
+              <a:rPr sz="900" b="0" i="0">
                 <a:solidFill>
                   <a:srgbClr val="000000"/>
                 </a:solidFill>
@@ -8507,8 +8507,8 @@
         </p:nvSpPr>
         <p:spPr>
           <a:xfrm>
-            <a:off x="7406640" y="541020"/>
-            <a:ext cx="2194560" cy="548640"/>
+            <a:off x="7287768" y="623316"/>
+            <a:ext cx="2221992" cy="739140"/>
           </a:xfrm>
           <a:prstGeom prst="rect">
             <a:avLst/>
@@ -8550,8 +8550,8 @@
         </p:nvSpPr>
         <p:spPr>
           <a:xfrm>
-            <a:off x="7470648" y="568452"/>
-            <a:ext cx="2194560" cy="128016"/>
+            <a:off x="7360920" y="659892"/>
+            <a:ext cx="2221992" cy="137160"/>
           </a:xfrm>
           <a:prstGeom prst="rect">
             <a:avLst/>
@@ -8585,23 +8585,23 @@
         </p:nvSpPr>
         <p:spPr>
           <a:xfrm>
-            <a:off x="7470648" y="705612"/>
-            <a:ext cx="2121408" cy="365760"/>
-          </a:xfrm>
-          <a:prstGeom prst="rect">
-            <a:avLst/>
-          </a:prstGeom>
-          <a:noFill/>
-        </p:spPr>
-        <p:txBody>
-          <a:bodyPr wrap="square">
-            <a:spAutoFit/>
-          </a:bodyPr>
-          <a:lstStyle/>
-          <a:p>
-            <a:pPr algn="l"/>
-            <a:r>
-              <a:rPr sz="800" b="0" i="0">
+            <a:off x="7360920" y="824484"/>
+            <a:ext cx="2148840" cy="510540"/>
+          </a:xfrm>
+          <a:prstGeom prst="rect">
+            <a:avLst/>
+          </a:prstGeom>
+          <a:noFill/>
+        </p:spPr>
+        <p:txBody>
+          <a:bodyPr wrap="square">
+            <a:spAutoFit/>
+          </a:bodyPr>
+          <a:lstStyle/>
+          <a:p>
+            <a:pPr algn="l"/>
+            <a:r>
+              <a:rPr sz="900" b="0" i="0">
                 <a:solidFill>
                   <a:srgbClr val="000000"/>
                 </a:solidFill>
@@ -8620,8 +8620,8 @@
         </p:nvSpPr>
         <p:spPr>
           <a:xfrm>
-            <a:off x="9692640" y="541020"/>
-            <a:ext cx="2194560" cy="548640"/>
+            <a:off x="9619488" y="623316"/>
+            <a:ext cx="2221992" cy="739140"/>
           </a:xfrm>
           <a:prstGeom prst="rect">
             <a:avLst/>
@@ -8663,8 +8663,8 @@
         </p:nvSpPr>
         <p:spPr>
           <a:xfrm>
-            <a:off x="9756648" y="568452"/>
-            <a:ext cx="2194560" cy="128016"/>
+            <a:off x="9692640" y="659892"/>
+            <a:ext cx="2221992" cy="137160"/>
           </a:xfrm>
           <a:prstGeom prst="rect">
             <a:avLst/>
@@ -8698,23 +8698,23 @@
         </p:nvSpPr>
         <p:spPr>
           <a:xfrm>
-            <a:off x="9756648" y="705612"/>
-            <a:ext cx="2121408" cy="365760"/>
-          </a:xfrm>
-          <a:prstGeom prst="rect">
-            <a:avLst/>
-          </a:prstGeom>
-          <a:noFill/>
-        </p:spPr>
-        <p:txBody>
-          <a:bodyPr wrap="square">
-            <a:spAutoFit/>
-          </a:bodyPr>
-          <a:lstStyle/>
-          <a:p>
-            <a:pPr algn="l"/>
-            <a:r>
-              <a:rPr sz="800" b="0" i="0">
+            <a:off x="9692640" y="824484"/>
+            <a:ext cx="2148840" cy="510540"/>
+          </a:xfrm>
+          <a:prstGeom prst="rect">
+            <a:avLst/>
+          </a:prstGeom>
+          <a:noFill/>
+        </p:spPr>
+        <p:txBody>
+          <a:bodyPr wrap="square">
+            <a:spAutoFit/>
+          </a:bodyPr>
+          <a:lstStyle/>
+          <a:p>
+            <a:pPr algn="l"/>
+            <a:r>
+              <a:rPr sz="900" b="0" i="0">
                 <a:solidFill>
                   <a:srgbClr val="000000"/>
                 </a:solidFill>
@@ -8733,7 +8733,7 @@
         </p:nvSpPr>
         <p:spPr>
           <a:xfrm>
-            <a:off x="0" y="1129030"/>
+            <a:off x="0" y="1410970"/>
             <a:ext cx="12188952" cy="6350"/>
           </a:xfrm>
           <a:prstGeom prst="rect">
@@ -8776,8 +8776,8 @@
         </p:nvSpPr>
         <p:spPr>
           <a:xfrm>
-            <a:off x="0" y="1135380"/>
-            <a:ext cx="12188952" cy="640080"/>
+            <a:off x="0" y="1417320"/>
+            <a:ext cx="12188952" cy="848868"/>
           </a:xfrm>
           <a:prstGeom prst="rect">
             <a:avLst/>
@@ -8819,8 +8819,8 @@
         </p:nvSpPr>
         <p:spPr>
           <a:xfrm>
-            <a:off x="256032" y="1171956"/>
-            <a:ext cx="4773168" cy="146304"/>
+            <a:off x="292608" y="1472184"/>
+            <a:ext cx="4562856" cy="164592"/>
           </a:xfrm>
           <a:prstGeom prst="rect">
             <a:avLst/>
@@ -8854,23 +8854,23 @@
         </p:nvSpPr>
         <p:spPr>
           <a:xfrm>
-            <a:off x="256032" y="1336548"/>
-            <a:ext cx="4773168" cy="420624"/>
-          </a:xfrm>
-          <a:prstGeom prst="rect">
-            <a:avLst/>
-          </a:prstGeom>
-          <a:noFill/>
-        </p:spPr>
-        <p:txBody>
-          <a:bodyPr wrap="square">
-            <a:spAutoFit/>
-          </a:bodyPr>
-          <a:lstStyle/>
-          <a:p>
-            <a:pPr algn="l"/>
-            <a:r>
-              <a:rPr sz="800" b="0" i="0">
+            <a:off x="292608" y="1673352"/>
+            <a:ext cx="4562856" cy="537972"/>
+          </a:xfrm>
+          <a:prstGeom prst="rect">
+            <a:avLst/>
+          </a:prstGeom>
+          <a:noFill/>
+        </p:spPr>
+        <p:txBody>
+          <a:bodyPr wrap="square">
+            <a:spAutoFit/>
+          </a:bodyPr>
+          <a:lstStyle/>
+          <a:p>
+            <a:pPr algn="l"/>
+            <a:r>
+              <a:rPr sz="900" b="0" i="0">
                 <a:solidFill>
                   <a:srgbClr val="595959"/>
                 </a:solidFill>
@@ -8889,8 +8889,8 @@
         </p:nvSpPr>
         <p:spPr>
           <a:xfrm>
-            <a:off x="5120640" y="1181100"/>
-            <a:ext cx="2194560" cy="548640"/>
+            <a:off x="4956048" y="1472184"/>
+            <a:ext cx="2221992" cy="739140"/>
           </a:xfrm>
           <a:prstGeom prst="rect">
             <a:avLst/>
@@ -8932,8 +8932,8 @@
         </p:nvSpPr>
         <p:spPr>
           <a:xfrm>
-            <a:off x="5184648" y="1208532"/>
-            <a:ext cx="2194560" cy="128016"/>
+            <a:off x="5029200" y="1508760"/>
+            <a:ext cx="2221992" cy="137160"/>
           </a:xfrm>
           <a:prstGeom prst="rect">
             <a:avLst/>
@@ -8967,23 +8967,23 @@
         </p:nvSpPr>
         <p:spPr>
           <a:xfrm>
-            <a:off x="5184648" y="1345692"/>
-            <a:ext cx="2121408" cy="365760"/>
-          </a:xfrm>
-          <a:prstGeom prst="rect">
-            <a:avLst/>
-          </a:prstGeom>
-          <a:noFill/>
-        </p:spPr>
-        <p:txBody>
-          <a:bodyPr wrap="square">
-            <a:spAutoFit/>
-          </a:bodyPr>
-          <a:lstStyle/>
-          <a:p>
-            <a:pPr algn="l"/>
-            <a:r>
-              <a:rPr sz="800" b="0" i="0">
+            <a:off x="5029200" y="1673352"/>
+            <a:ext cx="2148840" cy="510540"/>
+          </a:xfrm>
+          <a:prstGeom prst="rect">
+            <a:avLst/>
+          </a:prstGeom>
+          <a:noFill/>
+        </p:spPr>
+        <p:txBody>
+          <a:bodyPr wrap="square">
+            <a:spAutoFit/>
+          </a:bodyPr>
+          <a:lstStyle/>
+          <a:p>
+            <a:pPr algn="l"/>
+            <a:r>
+              <a:rPr sz="900" b="0" i="0">
                 <a:solidFill>
                   <a:srgbClr val="000000"/>
                 </a:solidFill>
@@ -9002,8 +9002,8 @@
         </p:nvSpPr>
         <p:spPr>
           <a:xfrm>
-            <a:off x="7406640" y="1181100"/>
-            <a:ext cx="2194560" cy="548640"/>
+            <a:off x="7287768" y="1472184"/>
+            <a:ext cx="2221992" cy="739140"/>
           </a:xfrm>
           <a:prstGeom prst="rect">
             <a:avLst/>
@@ -9045,8 +9045,8 @@
         </p:nvSpPr>
         <p:spPr>
           <a:xfrm>
-            <a:off x="7470648" y="1208532"/>
-            <a:ext cx="2194560" cy="128016"/>
+            <a:off x="7360920" y="1508760"/>
+            <a:ext cx="2221992" cy="137160"/>
           </a:xfrm>
           <a:prstGeom prst="rect">
             <a:avLst/>
@@ -9080,23 +9080,23 @@
         </p:nvSpPr>
         <p:spPr>
           <a:xfrm>
-            <a:off x="7470648" y="1345692"/>
-            <a:ext cx="2121408" cy="365760"/>
-          </a:xfrm>
-          <a:prstGeom prst="rect">
-            <a:avLst/>
-          </a:prstGeom>
-          <a:noFill/>
-        </p:spPr>
-        <p:txBody>
-          <a:bodyPr wrap="square">
-            <a:spAutoFit/>
-          </a:bodyPr>
-          <a:lstStyle/>
-          <a:p>
-            <a:pPr algn="l"/>
-            <a:r>
-              <a:rPr sz="800" b="0" i="0">
+            <a:off x="7360920" y="1673352"/>
+            <a:ext cx="2148840" cy="510540"/>
+          </a:xfrm>
+          <a:prstGeom prst="rect">
+            <a:avLst/>
+          </a:prstGeom>
+          <a:noFill/>
+        </p:spPr>
+        <p:txBody>
+          <a:bodyPr wrap="square">
+            <a:spAutoFit/>
+          </a:bodyPr>
+          <a:lstStyle/>
+          <a:p>
+            <a:pPr algn="l"/>
+            <a:r>
+              <a:rPr sz="900" b="0" i="0">
                 <a:solidFill>
                   <a:srgbClr val="000000"/>
                 </a:solidFill>
@@ -9115,8 +9115,8 @@
         </p:nvSpPr>
         <p:spPr>
           <a:xfrm>
-            <a:off x="9692640" y="1181100"/>
-            <a:ext cx="2194560" cy="548640"/>
+            <a:off x="9619488" y="1472184"/>
+            <a:ext cx="2221992" cy="739140"/>
           </a:xfrm>
           <a:prstGeom prst="rect">
             <a:avLst/>
@@ -9158,8 +9158,8 @@
         </p:nvSpPr>
         <p:spPr>
           <a:xfrm>
-            <a:off x="9756648" y="1208532"/>
-            <a:ext cx="2194560" cy="128016"/>
+            <a:off x="9692640" y="1508760"/>
+            <a:ext cx="2221992" cy="137160"/>
           </a:xfrm>
           <a:prstGeom prst="rect">
             <a:avLst/>
@@ -9193,23 +9193,23 @@
         </p:nvSpPr>
         <p:spPr>
           <a:xfrm>
-            <a:off x="9756648" y="1345692"/>
-            <a:ext cx="2121408" cy="365760"/>
-          </a:xfrm>
-          <a:prstGeom prst="rect">
-            <a:avLst/>
-          </a:prstGeom>
-          <a:noFill/>
-        </p:spPr>
-        <p:txBody>
-          <a:bodyPr wrap="square">
-            <a:spAutoFit/>
-          </a:bodyPr>
-          <a:lstStyle/>
-          <a:p>
-            <a:pPr algn="l"/>
-            <a:r>
-              <a:rPr sz="800" b="0" i="0">
+            <a:off x="9692640" y="1673352"/>
+            <a:ext cx="2148840" cy="510540"/>
+          </a:xfrm>
+          <a:prstGeom prst="rect">
+            <a:avLst/>
+          </a:prstGeom>
+          <a:noFill/>
+        </p:spPr>
+        <p:txBody>
+          <a:bodyPr wrap="square">
+            <a:spAutoFit/>
+          </a:bodyPr>
+          <a:lstStyle/>
+          <a:p>
+            <a:pPr algn="l"/>
+            <a:r>
+              <a:rPr sz="900" b="0" i="0">
                 <a:solidFill>
                   <a:srgbClr val="000000"/>
                 </a:solidFill>
@@ -9228,7 +9228,7 @@
         </p:nvSpPr>
         <p:spPr>
           <a:xfrm>
-            <a:off x="0" y="1769110"/>
+            <a:off x="0" y="2259838"/>
             <a:ext cx="12188952" cy="6350"/>
           </a:xfrm>
           <a:prstGeom prst="rect">
@@ -9271,8 +9271,8 @@
         </p:nvSpPr>
         <p:spPr>
           <a:xfrm>
-            <a:off x="0" y="1775460"/>
-            <a:ext cx="12188952" cy="640080"/>
+            <a:off x="0" y="2266188"/>
+            <a:ext cx="12188952" cy="848868"/>
           </a:xfrm>
           <a:prstGeom prst="rect">
             <a:avLst/>
@@ -9314,8 +9314,8 @@
         </p:nvSpPr>
         <p:spPr>
           <a:xfrm>
-            <a:off x="256032" y="1812036"/>
-            <a:ext cx="4773168" cy="146304"/>
+            <a:off x="292608" y="2321052"/>
+            <a:ext cx="4562856" cy="164592"/>
           </a:xfrm>
           <a:prstGeom prst="rect">
             <a:avLst/>
@@ -9349,23 +9349,23 @@
         </p:nvSpPr>
         <p:spPr>
           <a:xfrm>
-            <a:off x="256032" y="1976628"/>
-            <a:ext cx="4773168" cy="420624"/>
-          </a:xfrm>
-          <a:prstGeom prst="rect">
-            <a:avLst/>
-          </a:prstGeom>
-          <a:noFill/>
-        </p:spPr>
-        <p:txBody>
-          <a:bodyPr wrap="square">
-            <a:spAutoFit/>
-          </a:bodyPr>
-          <a:lstStyle/>
-          <a:p>
-            <a:pPr algn="l"/>
-            <a:r>
-              <a:rPr sz="800" b="0" i="0">
+            <a:off x="292608" y="2522220"/>
+            <a:ext cx="4562856" cy="537972"/>
+          </a:xfrm>
+          <a:prstGeom prst="rect">
+            <a:avLst/>
+          </a:prstGeom>
+          <a:noFill/>
+        </p:spPr>
+        <p:txBody>
+          <a:bodyPr wrap="square">
+            <a:spAutoFit/>
+          </a:bodyPr>
+          <a:lstStyle/>
+          <a:p>
+            <a:pPr algn="l"/>
+            <a:r>
+              <a:rPr sz="900" b="0" i="0">
                 <a:solidFill>
                   <a:srgbClr val="595959"/>
                 </a:solidFill>
@@ -9384,8 +9384,8 @@
         </p:nvSpPr>
         <p:spPr>
           <a:xfrm>
-            <a:off x="5120640" y="1821180"/>
-            <a:ext cx="2194560" cy="548640"/>
+            <a:off x="4956048" y="2321052"/>
+            <a:ext cx="2221992" cy="739140"/>
           </a:xfrm>
           <a:prstGeom prst="rect">
             <a:avLst/>
@@ -9427,8 +9427,8 @@
         </p:nvSpPr>
         <p:spPr>
           <a:xfrm>
-            <a:off x="5184648" y="1848612"/>
-            <a:ext cx="2194560" cy="128016"/>
+            <a:off x="5029200" y="2357628"/>
+            <a:ext cx="2221992" cy="137160"/>
           </a:xfrm>
           <a:prstGeom prst="rect">
             <a:avLst/>
@@ -9462,23 +9462,23 @@
         </p:nvSpPr>
         <p:spPr>
           <a:xfrm>
-            <a:off x="5184648" y="1985772"/>
-            <a:ext cx="2121408" cy="365760"/>
-          </a:xfrm>
-          <a:prstGeom prst="rect">
-            <a:avLst/>
-          </a:prstGeom>
-          <a:noFill/>
-        </p:spPr>
-        <p:txBody>
-          <a:bodyPr wrap="square">
-            <a:spAutoFit/>
-          </a:bodyPr>
-          <a:lstStyle/>
-          <a:p>
-            <a:pPr algn="l"/>
-            <a:r>
-              <a:rPr sz="800" b="0" i="0">
+            <a:off x="5029200" y="2522220"/>
+            <a:ext cx="2148840" cy="510540"/>
+          </a:xfrm>
+          <a:prstGeom prst="rect">
+            <a:avLst/>
+          </a:prstGeom>
+          <a:noFill/>
+        </p:spPr>
+        <p:txBody>
+          <a:bodyPr wrap="square">
+            <a:spAutoFit/>
+          </a:bodyPr>
+          <a:lstStyle/>
+          <a:p>
+            <a:pPr algn="l"/>
+            <a:r>
+              <a:rPr sz="900" b="0" i="0">
                 <a:solidFill>
                   <a:srgbClr val="000000"/>
                 </a:solidFill>
@@ -9497,8 +9497,8 @@
         </p:nvSpPr>
         <p:spPr>
           <a:xfrm>
-            <a:off x="7406640" y="1821180"/>
-            <a:ext cx="2194560" cy="548640"/>
+            <a:off x="7287768" y="2321052"/>
+            <a:ext cx="2221992" cy="739140"/>
           </a:xfrm>
           <a:prstGeom prst="rect">
             <a:avLst/>
@@ -9540,8 +9540,8 @@
         </p:nvSpPr>
         <p:spPr>
           <a:xfrm>
-            <a:off x="7470648" y="1848612"/>
-            <a:ext cx="2194560" cy="128016"/>
+            <a:off x="7360920" y="2357628"/>
+            <a:ext cx="2221992" cy="137160"/>
           </a:xfrm>
           <a:prstGeom prst="rect">
             <a:avLst/>
@@ -9575,23 +9575,23 @@
         </p:nvSpPr>
         <p:spPr>
           <a:xfrm>
-            <a:off x="7470648" y="1985772"/>
-            <a:ext cx="2121408" cy="365760"/>
-          </a:xfrm>
-          <a:prstGeom prst="rect">
-            <a:avLst/>
-          </a:prstGeom>
-          <a:noFill/>
-        </p:spPr>
-        <p:txBody>
-          <a:bodyPr wrap="square">
-            <a:spAutoFit/>
-          </a:bodyPr>
-          <a:lstStyle/>
-          <a:p>
-            <a:pPr algn="l"/>
-            <a:r>
-              <a:rPr sz="800" b="0" i="0">
+            <a:off x="7360920" y="2522220"/>
+            <a:ext cx="2148840" cy="510540"/>
+          </a:xfrm>
+          <a:prstGeom prst="rect">
+            <a:avLst/>
+          </a:prstGeom>
+          <a:noFill/>
+        </p:spPr>
+        <p:txBody>
+          <a:bodyPr wrap="square">
+            <a:spAutoFit/>
+          </a:bodyPr>
+          <a:lstStyle/>
+          <a:p>
+            <a:pPr algn="l"/>
+            <a:r>
+              <a:rPr sz="900" b="0" i="0">
                 <a:solidFill>
                   <a:srgbClr val="000000"/>
                 </a:solidFill>
@@ -9610,8 +9610,8 @@
         </p:nvSpPr>
         <p:spPr>
           <a:xfrm>
-            <a:off x="9692640" y="1821180"/>
-            <a:ext cx="2194560" cy="548640"/>
+            <a:off x="9619488" y="2321052"/>
+            <a:ext cx="2221992" cy="739140"/>
           </a:xfrm>
           <a:prstGeom prst="rect">
             <a:avLst/>
@@ -9653,8 +9653,8 @@
         </p:nvSpPr>
         <p:spPr>
           <a:xfrm>
-            <a:off x="9756648" y="1848612"/>
-            <a:ext cx="2194560" cy="128016"/>
+            <a:off x="9692640" y="2357628"/>
+            <a:ext cx="2221992" cy="137160"/>
           </a:xfrm>
           <a:prstGeom prst="rect">
             <a:avLst/>
@@ -9688,23 +9688,23 @@
         </p:nvSpPr>
         <p:spPr>
           <a:xfrm>
-            <a:off x="9756648" y="1985772"/>
-            <a:ext cx="2121408" cy="365760"/>
-          </a:xfrm>
-          <a:prstGeom prst="rect">
-            <a:avLst/>
-          </a:prstGeom>
-          <a:noFill/>
-        </p:spPr>
-        <p:txBody>
-          <a:bodyPr wrap="square">
-            <a:spAutoFit/>
-          </a:bodyPr>
-          <a:lstStyle/>
-          <a:p>
-            <a:pPr algn="l"/>
-            <a:r>
-              <a:rPr sz="800" b="0" i="0">
+            <a:off x="9692640" y="2522220"/>
+            <a:ext cx="2148840" cy="510540"/>
+          </a:xfrm>
+          <a:prstGeom prst="rect">
+            <a:avLst/>
+          </a:prstGeom>
+          <a:noFill/>
+        </p:spPr>
+        <p:txBody>
+          <a:bodyPr wrap="square">
+            <a:spAutoFit/>
+          </a:bodyPr>
+          <a:lstStyle/>
+          <a:p>
+            <a:pPr algn="l"/>
+            <a:r>
+              <a:rPr sz="900" b="0" i="0">
                 <a:solidFill>
                   <a:srgbClr val="000000"/>
                 </a:solidFill>
@@ -9723,7 +9723,7 @@
         </p:nvSpPr>
         <p:spPr>
           <a:xfrm>
-            <a:off x="0" y="2409190"/>
+            <a:off x="0" y="3108706"/>
             <a:ext cx="12188952" cy="6350"/>
           </a:xfrm>
           <a:prstGeom prst="rect">
@@ -9766,8 +9766,8 @@
         </p:nvSpPr>
         <p:spPr>
           <a:xfrm>
-            <a:off x="0" y="2415540"/>
-            <a:ext cx="12188952" cy="640080"/>
+            <a:off x="0" y="3115056"/>
+            <a:ext cx="12188952" cy="848868"/>
           </a:xfrm>
           <a:prstGeom prst="rect">
             <a:avLst/>
@@ -9809,8 +9809,8 @@
         </p:nvSpPr>
         <p:spPr>
           <a:xfrm>
-            <a:off x="256032" y="2452116"/>
-            <a:ext cx="4773168" cy="146304"/>
+            <a:off x="292608" y="3169920"/>
+            <a:ext cx="4562856" cy="164592"/>
           </a:xfrm>
           <a:prstGeom prst="rect">
             <a:avLst/>
@@ -9844,23 +9844,23 @@
         </p:nvSpPr>
         <p:spPr>
           <a:xfrm>
-            <a:off x="256032" y="2616708"/>
-            <a:ext cx="4773168" cy="420624"/>
-          </a:xfrm>
-          <a:prstGeom prst="rect">
-            <a:avLst/>
-          </a:prstGeom>
-          <a:noFill/>
-        </p:spPr>
-        <p:txBody>
-          <a:bodyPr wrap="square">
-            <a:spAutoFit/>
-          </a:bodyPr>
-          <a:lstStyle/>
-          <a:p>
-            <a:pPr algn="l"/>
-            <a:r>
-              <a:rPr sz="800" b="0" i="0">
+            <a:off x="292608" y="3371088"/>
+            <a:ext cx="4562856" cy="537972"/>
+          </a:xfrm>
+          <a:prstGeom prst="rect">
+            <a:avLst/>
+          </a:prstGeom>
+          <a:noFill/>
+        </p:spPr>
+        <p:txBody>
+          <a:bodyPr wrap="square">
+            <a:spAutoFit/>
+          </a:bodyPr>
+          <a:lstStyle/>
+          <a:p>
+            <a:pPr algn="l"/>
+            <a:r>
+              <a:rPr sz="900" b="0" i="0">
                 <a:solidFill>
                   <a:srgbClr val="595959"/>
                 </a:solidFill>
@@ -9879,8 +9879,8 @@
         </p:nvSpPr>
         <p:spPr>
           <a:xfrm>
-            <a:off x="5120640" y="2461260"/>
-            <a:ext cx="2194560" cy="548640"/>
+            <a:off x="4956048" y="3169920"/>
+            <a:ext cx="2221992" cy="739140"/>
           </a:xfrm>
           <a:prstGeom prst="rect">
             <a:avLst/>
@@ -9922,8 +9922,8 @@
         </p:nvSpPr>
         <p:spPr>
           <a:xfrm>
-            <a:off x="5184648" y="2488692"/>
-            <a:ext cx="2194560" cy="128016"/>
+            <a:off x="5029200" y="3206496"/>
+            <a:ext cx="2221992" cy="137160"/>
           </a:xfrm>
           <a:prstGeom prst="rect">
             <a:avLst/>
@@ -9957,23 +9957,23 @@
         </p:nvSpPr>
         <p:spPr>
           <a:xfrm>
-            <a:off x="5184648" y="2625852"/>
-            <a:ext cx="2121408" cy="365760"/>
-          </a:xfrm>
-          <a:prstGeom prst="rect">
-            <a:avLst/>
-          </a:prstGeom>
-          <a:noFill/>
-        </p:spPr>
-        <p:txBody>
-          <a:bodyPr wrap="square">
-            <a:spAutoFit/>
-          </a:bodyPr>
-          <a:lstStyle/>
-          <a:p>
-            <a:pPr algn="l"/>
-            <a:r>
-              <a:rPr sz="800" b="0" i="0">
+            <a:off x="5029200" y="3371088"/>
+            <a:ext cx="2148840" cy="510540"/>
+          </a:xfrm>
+          <a:prstGeom prst="rect">
+            <a:avLst/>
+          </a:prstGeom>
+          <a:noFill/>
+        </p:spPr>
+        <p:txBody>
+          <a:bodyPr wrap="square">
+            <a:spAutoFit/>
+          </a:bodyPr>
+          <a:lstStyle/>
+          <a:p>
+            <a:pPr algn="l"/>
+            <a:r>
+              <a:rPr sz="900" b="0" i="0">
                 <a:solidFill>
                   <a:srgbClr val="000000"/>
                 </a:solidFill>
@@ -9992,8 +9992,8 @@
         </p:nvSpPr>
         <p:spPr>
           <a:xfrm>
-            <a:off x="7406640" y="2461260"/>
-            <a:ext cx="2194560" cy="548640"/>
+            <a:off x="7287768" y="3169920"/>
+            <a:ext cx="2221992" cy="739140"/>
           </a:xfrm>
           <a:prstGeom prst="rect">
             <a:avLst/>
@@ -10035,8 +10035,8 @@
         </p:nvSpPr>
         <p:spPr>
           <a:xfrm>
-            <a:off x="7470648" y="2488692"/>
-            <a:ext cx="2194560" cy="128016"/>
+            <a:off x="7360920" y="3206496"/>
+            <a:ext cx="2221992" cy="137160"/>
           </a:xfrm>
           <a:prstGeom prst="rect">
             <a:avLst/>
@@ -10070,23 +10070,23 @@
         </p:nvSpPr>
         <p:spPr>
           <a:xfrm>
-            <a:off x="7470648" y="2625852"/>
-            <a:ext cx="2121408" cy="365760"/>
-          </a:xfrm>
-          <a:prstGeom prst="rect">
-            <a:avLst/>
-          </a:prstGeom>
-          <a:noFill/>
-        </p:spPr>
-        <p:txBody>
-          <a:bodyPr wrap="square">
-            <a:spAutoFit/>
-          </a:bodyPr>
-          <a:lstStyle/>
-          <a:p>
-            <a:pPr algn="l"/>
-            <a:r>
-              <a:rPr sz="800" b="0" i="0">
+            <a:off x="7360920" y="3371088"/>
+            <a:ext cx="2148840" cy="510540"/>
+          </a:xfrm>
+          <a:prstGeom prst="rect">
+            <a:avLst/>
+          </a:prstGeom>
+          <a:noFill/>
+        </p:spPr>
+        <p:txBody>
+          <a:bodyPr wrap="square">
+            <a:spAutoFit/>
+          </a:bodyPr>
+          <a:lstStyle/>
+          <a:p>
+            <a:pPr algn="l"/>
+            <a:r>
+              <a:rPr sz="900" b="0" i="0">
                 <a:solidFill>
                   <a:srgbClr val="000000"/>
                 </a:solidFill>
@@ -10105,8 +10105,8 @@
         </p:nvSpPr>
         <p:spPr>
           <a:xfrm>
-            <a:off x="9692640" y="2461260"/>
-            <a:ext cx="2194560" cy="548640"/>
+            <a:off x="9619488" y="3169920"/>
+            <a:ext cx="2221992" cy="739140"/>
           </a:xfrm>
           <a:prstGeom prst="rect">
             <a:avLst/>
@@ -10148,8 +10148,8 @@
         </p:nvSpPr>
         <p:spPr>
           <a:xfrm>
-            <a:off x="9756648" y="2488692"/>
-            <a:ext cx="2194560" cy="128016"/>
+            <a:off x="9692640" y="3206496"/>
+            <a:ext cx="2221992" cy="137160"/>
           </a:xfrm>
           <a:prstGeom prst="rect">
             <a:avLst/>
@@ -10183,23 +10183,23 @@
         </p:nvSpPr>
         <p:spPr>
           <a:xfrm>
-            <a:off x="9756648" y="2625852"/>
-            <a:ext cx="2121408" cy="365760"/>
-          </a:xfrm>
-          <a:prstGeom prst="rect">
-            <a:avLst/>
-          </a:prstGeom>
-          <a:noFill/>
-        </p:spPr>
-        <p:txBody>
-          <a:bodyPr wrap="square">
-            <a:spAutoFit/>
-          </a:bodyPr>
-          <a:lstStyle/>
-          <a:p>
-            <a:pPr algn="l"/>
-            <a:r>
-              <a:rPr sz="800" b="0" i="0">
+            <a:off x="9692640" y="3371088"/>
+            <a:ext cx="2148840" cy="510540"/>
+          </a:xfrm>
+          <a:prstGeom prst="rect">
+            <a:avLst/>
+          </a:prstGeom>
+          <a:noFill/>
+        </p:spPr>
+        <p:txBody>
+          <a:bodyPr wrap="square">
+            <a:spAutoFit/>
+          </a:bodyPr>
+          <a:lstStyle/>
+          <a:p>
+            <a:pPr algn="l"/>
+            <a:r>
+              <a:rPr sz="900" b="0" i="0">
                 <a:solidFill>
                   <a:srgbClr val="000000"/>
                 </a:solidFill>
@@ -10218,7 +10218,7 @@
         </p:nvSpPr>
         <p:spPr>
           <a:xfrm>
-            <a:off x="0" y="3049270"/>
+            <a:off x="0" y="3957574"/>
             <a:ext cx="12188952" cy="6350"/>
           </a:xfrm>
           <a:prstGeom prst="rect">
@@ -10261,8 +10261,8 @@
         </p:nvSpPr>
         <p:spPr>
           <a:xfrm>
-            <a:off x="0" y="3101340"/>
-            <a:ext cx="12188952" cy="201168"/>
+            <a:off x="0" y="4018788"/>
+            <a:ext cx="12188952" cy="237744"/>
           </a:xfrm>
           <a:prstGeom prst="rect">
             <a:avLst/>
@@ -10304,23 +10304,23 @@
         </p:nvSpPr>
         <p:spPr>
           <a:xfrm>
-            <a:off x="256032" y="3128772"/>
-            <a:ext cx="4818888" cy="201168"/>
-          </a:xfrm>
-          <a:prstGeom prst="rect">
-            <a:avLst/>
-          </a:prstGeom>
-          <a:noFill/>
-        </p:spPr>
-        <p:txBody>
-          <a:bodyPr wrap="square">
-            <a:spAutoFit/>
-          </a:bodyPr>
-          <a:lstStyle/>
-          <a:p>
-            <a:pPr algn="l"/>
-            <a:r>
-              <a:rPr sz="800" b="1" i="0">
+            <a:off x="292608" y="4055364"/>
+            <a:ext cx="4608576" cy="201168"/>
+          </a:xfrm>
+          <a:prstGeom prst="rect">
+            <a:avLst/>
+          </a:prstGeom>
+          <a:noFill/>
+        </p:spPr>
+        <p:txBody>
+          <a:bodyPr wrap="square">
+            <a:spAutoFit/>
+          </a:bodyPr>
+          <a:lstStyle/>
+          <a:p>
+            <a:pPr algn="l"/>
+            <a:r>
+              <a:rPr sz="900" b="1" i="0">
                 <a:solidFill>
                   <a:srgbClr val="FFFFFF"/>
                 </a:solidFill>
@@ -10339,8 +10339,8 @@
         </p:nvSpPr>
         <p:spPr>
           <a:xfrm>
-            <a:off x="0" y="3302508"/>
-            <a:ext cx="12188952" cy="640080"/>
+            <a:off x="0" y="4256532"/>
+            <a:ext cx="12188952" cy="848868"/>
           </a:xfrm>
           <a:prstGeom prst="rect">
             <a:avLst/>
@@ -10382,8 +10382,8 @@
         </p:nvSpPr>
         <p:spPr>
           <a:xfrm>
-            <a:off x="256032" y="3339084"/>
-            <a:ext cx="4773168" cy="146304"/>
+            <a:off x="292608" y="4311396"/>
+            <a:ext cx="4562856" cy="164592"/>
           </a:xfrm>
           <a:prstGeom prst="rect">
             <a:avLst/>
@@ -10417,23 +10417,23 @@
         </p:nvSpPr>
         <p:spPr>
           <a:xfrm>
-            <a:off x="256032" y="3503676"/>
-            <a:ext cx="4773168" cy="420624"/>
-          </a:xfrm>
-          <a:prstGeom prst="rect">
-            <a:avLst/>
-          </a:prstGeom>
-          <a:noFill/>
-        </p:spPr>
-        <p:txBody>
-          <a:bodyPr wrap="square">
-            <a:spAutoFit/>
-          </a:bodyPr>
-          <a:lstStyle/>
-          <a:p>
-            <a:pPr algn="l"/>
-            <a:r>
-              <a:rPr sz="800" b="0" i="0">
+            <a:off x="292608" y="4512564"/>
+            <a:ext cx="4562856" cy="537972"/>
+          </a:xfrm>
+          <a:prstGeom prst="rect">
+            <a:avLst/>
+          </a:prstGeom>
+          <a:noFill/>
+        </p:spPr>
+        <p:txBody>
+          <a:bodyPr wrap="square">
+            <a:spAutoFit/>
+          </a:bodyPr>
+          <a:lstStyle/>
+          <a:p>
+            <a:pPr algn="l"/>
+            <a:r>
+              <a:rPr sz="900" b="0" i="0">
                 <a:solidFill>
                   <a:srgbClr val="595959"/>
                 </a:solidFill>
@@ -10452,8 +10452,8 @@
         </p:nvSpPr>
         <p:spPr>
           <a:xfrm>
-            <a:off x="5120640" y="3348228"/>
-            <a:ext cx="2194560" cy="548640"/>
+            <a:off x="4956048" y="4311396"/>
+            <a:ext cx="2221992" cy="739140"/>
           </a:xfrm>
           <a:prstGeom prst="rect">
             <a:avLst/>
@@ -10495,8 +10495,8 @@
         </p:nvSpPr>
         <p:spPr>
           <a:xfrm>
-            <a:off x="5184648" y="3375660"/>
-            <a:ext cx="2194560" cy="128016"/>
+            <a:off x="5029200" y="4347972"/>
+            <a:ext cx="2221992" cy="137160"/>
           </a:xfrm>
           <a:prstGeom prst="rect">
             <a:avLst/>
@@ -10530,23 +10530,23 @@
         </p:nvSpPr>
         <p:spPr>
           <a:xfrm>
-            <a:off x="5184648" y="3512820"/>
-            <a:ext cx="2121408" cy="365760"/>
-          </a:xfrm>
-          <a:prstGeom prst="rect">
-            <a:avLst/>
-          </a:prstGeom>
-          <a:noFill/>
-        </p:spPr>
-        <p:txBody>
-          <a:bodyPr wrap="square">
-            <a:spAutoFit/>
-          </a:bodyPr>
-          <a:lstStyle/>
-          <a:p>
-            <a:pPr algn="l"/>
-            <a:r>
-              <a:rPr sz="800" b="0" i="0">
+            <a:off x="5029200" y="4512564"/>
+            <a:ext cx="2148840" cy="510540"/>
+          </a:xfrm>
+          <a:prstGeom prst="rect">
+            <a:avLst/>
+          </a:prstGeom>
+          <a:noFill/>
+        </p:spPr>
+        <p:txBody>
+          <a:bodyPr wrap="square">
+            <a:spAutoFit/>
+          </a:bodyPr>
+          <a:lstStyle/>
+          <a:p>
+            <a:pPr algn="l"/>
+            <a:r>
+              <a:rPr sz="900" b="0" i="0">
                 <a:solidFill>
                   <a:srgbClr val="000000"/>
                 </a:solidFill>
@@ -10565,8 +10565,8 @@
         </p:nvSpPr>
         <p:spPr>
           <a:xfrm>
-            <a:off x="7406640" y="3348228"/>
-            <a:ext cx="2194560" cy="548640"/>
+            <a:off x="7287768" y="4311396"/>
+            <a:ext cx="2221992" cy="739140"/>
           </a:xfrm>
           <a:prstGeom prst="rect">
             <a:avLst/>
@@ -10608,8 +10608,8 @@
         </p:nvSpPr>
         <p:spPr>
           <a:xfrm>
-            <a:off x="7470648" y="3375660"/>
-            <a:ext cx="2194560" cy="128016"/>
+            <a:off x="7360920" y="4347972"/>
+            <a:ext cx="2221992" cy="137160"/>
           </a:xfrm>
           <a:prstGeom prst="rect">
             <a:avLst/>
@@ -10643,23 +10643,23 @@
         </p:nvSpPr>
         <p:spPr>
           <a:xfrm>
-            <a:off x="7470648" y="3512820"/>
-            <a:ext cx="2121408" cy="365760"/>
-          </a:xfrm>
-          <a:prstGeom prst="rect">
-            <a:avLst/>
-          </a:prstGeom>
-          <a:noFill/>
-        </p:spPr>
-        <p:txBody>
-          <a:bodyPr wrap="square">
-            <a:spAutoFit/>
-          </a:bodyPr>
-          <a:lstStyle/>
-          <a:p>
-            <a:pPr algn="l"/>
-            <a:r>
-              <a:rPr sz="800" b="0" i="0">
+            <a:off x="7360920" y="4512564"/>
+            <a:ext cx="2148840" cy="510540"/>
+          </a:xfrm>
+          <a:prstGeom prst="rect">
+            <a:avLst/>
+          </a:prstGeom>
+          <a:noFill/>
+        </p:spPr>
+        <p:txBody>
+          <a:bodyPr wrap="square">
+            <a:spAutoFit/>
+          </a:bodyPr>
+          <a:lstStyle/>
+          <a:p>
+            <a:pPr algn="l"/>
+            <a:r>
+              <a:rPr sz="900" b="0" i="0">
                 <a:solidFill>
                   <a:srgbClr val="000000"/>
                 </a:solidFill>
@@ -10678,8 +10678,8 @@
         </p:nvSpPr>
         <p:spPr>
           <a:xfrm>
-            <a:off x="9692640" y="3348228"/>
-            <a:ext cx="2194560" cy="548640"/>
+            <a:off x="9619488" y="4311396"/>
+            <a:ext cx="2221992" cy="739140"/>
           </a:xfrm>
           <a:prstGeom prst="rect">
             <a:avLst/>
@@ -10721,8 +10721,8 @@
         </p:nvSpPr>
         <p:spPr>
           <a:xfrm>
-            <a:off x="9756648" y="3375660"/>
-            <a:ext cx="2194560" cy="128016"/>
+            <a:off x="9692640" y="4347972"/>
+            <a:ext cx="2221992" cy="137160"/>
           </a:xfrm>
           <a:prstGeom prst="rect">
             <a:avLst/>
@@ -10756,23 +10756,23 @@
         </p:nvSpPr>
         <p:spPr>
           <a:xfrm>
-            <a:off x="9756648" y="3512820"/>
-            <a:ext cx="2121408" cy="365760"/>
-          </a:xfrm>
-          <a:prstGeom prst="rect">
-            <a:avLst/>
-          </a:prstGeom>
-          <a:noFill/>
-        </p:spPr>
-        <p:txBody>
-          <a:bodyPr wrap="square">
-            <a:spAutoFit/>
-          </a:bodyPr>
-          <a:lstStyle/>
-          <a:p>
-            <a:pPr algn="l"/>
-            <a:r>
-              <a:rPr sz="800" b="0" i="0">
+            <a:off x="9692640" y="4512564"/>
+            <a:ext cx="2148840" cy="510540"/>
+          </a:xfrm>
+          <a:prstGeom prst="rect">
+            <a:avLst/>
+          </a:prstGeom>
+          <a:noFill/>
+        </p:spPr>
+        <p:txBody>
+          <a:bodyPr wrap="square">
+            <a:spAutoFit/>
+          </a:bodyPr>
+          <a:lstStyle/>
+          <a:p>
+            <a:pPr algn="l"/>
+            <a:r>
+              <a:rPr sz="900" b="0" i="0">
                 <a:solidFill>
                   <a:srgbClr val="000000"/>
                 </a:solidFill>
@@ -10791,7 +10791,7 @@
         </p:nvSpPr>
         <p:spPr>
           <a:xfrm>
-            <a:off x="0" y="3936238"/>
+            <a:off x="0" y="5099050"/>
             <a:ext cx="12188952" cy="6350"/>
           </a:xfrm>
           <a:prstGeom prst="rect">
@@ -10834,8 +10834,8 @@
         </p:nvSpPr>
         <p:spPr>
           <a:xfrm>
-            <a:off x="0" y="3942588"/>
-            <a:ext cx="12188952" cy="640080"/>
+            <a:off x="0" y="5105400"/>
+            <a:ext cx="12188952" cy="848868"/>
           </a:xfrm>
           <a:prstGeom prst="rect">
             <a:avLst/>
@@ -10877,8 +10877,8 @@
         </p:nvSpPr>
         <p:spPr>
           <a:xfrm>
-            <a:off x="256032" y="3979164"/>
-            <a:ext cx="4773168" cy="146304"/>
+            <a:off x="292608" y="5160264"/>
+            <a:ext cx="4562856" cy="164592"/>
           </a:xfrm>
           <a:prstGeom prst="rect">
             <a:avLst/>
@@ -10912,23 +10912,23 @@
         </p:nvSpPr>
         <p:spPr>
           <a:xfrm>
-            <a:off x="256032" y="4143756"/>
-            <a:ext cx="4773168" cy="420624"/>
-          </a:xfrm>
-          <a:prstGeom prst="rect">
-            <a:avLst/>
-          </a:prstGeom>
-          <a:noFill/>
-        </p:spPr>
-        <p:txBody>
-          <a:bodyPr wrap="square">
-            <a:spAutoFit/>
-          </a:bodyPr>
-          <a:lstStyle/>
-          <a:p>
-            <a:pPr algn="l"/>
-            <a:r>
-              <a:rPr sz="800" b="0" i="0">
+            <a:off x="292608" y="5361432"/>
+            <a:ext cx="4562856" cy="537972"/>
+          </a:xfrm>
+          <a:prstGeom prst="rect">
+            <a:avLst/>
+          </a:prstGeom>
+          <a:noFill/>
+        </p:spPr>
+        <p:txBody>
+          <a:bodyPr wrap="square">
+            <a:spAutoFit/>
+          </a:bodyPr>
+          <a:lstStyle/>
+          <a:p>
+            <a:pPr algn="l"/>
+            <a:r>
+              <a:rPr sz="900" b="0" i="0">
                 <a:solidFill>
                   <a:srgbClr val="595959"/>
                 </a:solidFill>
@@ -10947,8 +10947,8 @@
         </p:nvSpPr>
         <p:spPr>
           <a:xfrm>
-            <a:off x="5120640" y="3988308"/>
-            <a:ext cx="2194560" cy="548640"/>
+            <a:off x="4956048" y="5160264"/>
+            <a:ext cx="2221992" cy="739140"/>
           </a:xfrm>
           <a:prstGeom prst="rect">
             <a:avLst/>
@@ -10990,8 +10990,8 @@
         </p:nvSpPr>
         <p:spPr>
           <a:xfrm>
-            <a:off x="5184648" y="4015740"/>
-            <a:ext cx="2194560" cy="128016"/>
+            <a:off x="5029200" y="5196840"/>
+            <a:ext cx="2221992" cy="137160"/>
           </a:xfrm>
           <a:prstGeom prst="rect">
             <a:avLst/>
@@ -11025,23 +11025,23 @@
         </p:nvSpPr>
         <p:spPr>
           <a:xfrm>
-            <a:off x="5184648" y="4152900"/>
-            <a:ext cx="2121408" cy="365760"/>
-          </a:xfrm>
-          <a:prstGeom prst="rect">
-            <a:avLst/>
-          </a:prstGeom>
-          <a:noFill/>
-        </p:spPr>
-        <p:txBody>
-          <a:bodyPr wrap="square">
-            <a:spAutoFit/>
-          </a:bodyPr>
-          <a:lstStyle/>
-          <a:p>
-            <a:pPr algn="l"/>
-            <a:r>
-              <a:rPr sz="800" b="0" i="0">
+            <a:off x="5029200" y="5361432"/>
+            <a:ext cx="2148840" cy="510540"/>
+          </a:xfrm>
+          <a:prstGeom prst="rect">
+            <a:avLst/>
+          </a:prstGeom>
+          <a:noFill/>
+        </p:spPr>
+        <p:txBody>
+          <a:bodyPr wrap="square">
+            <a:spAutoFit/>
+          </a:bodyPr>
+          <a:lstStyle/>
+          <a:p>
+            <a:pPr algn="l"/>
+            <a:r>
+              <a:rPr sz="900" b="0" i="0">
                 <a:solidFill>
                   <a:srgbClr val="000000"/>
                 </a:solidFill>
@@ -11060,8 +11060,8 @@
         </p:nvSpPr>
         <p:spPr>
           <a:xfrm>
-            <a:off x="7406640" y="3988308"/>
-            <a:ext cx="2194560" cy="548640"/>
+            <a:off x="7287768" y="5160264"/>
+            <a:ext cx="2221992" cy="739140"/>
           </a:xfrm>
           <a:prstGeom prst="rect">
             <a:avLst/>
@@ -11103,8 +11103,8 @@
         </p:nvSpPr>
         <p:spPr>
           <a:xfrm>
-            <a:off x="7470648" y="4015740"/>
-            <a:ext cx="2194560" cy="128016"/>
+            <a:off x="7360920" y="5196840"/>
+            <a:ext cx="2221992" cy="137160"/>
           </a:xfrm>
           <a:prstGeom prst="rect">
             <a:avLst/>
@@ -11138,23 +11138,23 @@
         </p:nvSpPr>
         <p:spPr>
           <a:xfrm>
-            <a:off x="7470648" y="4152900"/>
-            <a:ext cx="2121408" cy="365760"/>
-          </a:xfrm>
-          <a:prstGeom prst="rect">
-            <a:avLst/>
-          </a:prstGeom>
-          <a:noFill/>
-        </p:spPr>
-        <p:txBody>
-          <a:bodyPr wrap="square">
-            <a:spAutoFit/>
-          </a:bodyPr>
-          <a:lstStyle/>
-          <a:p>
-            <a:pPr algn="l"/>
-            <a:r>
-              <a:rPr sz="800" b="0" i="0">
+            <a:off x="7360920" y="5361432"/>
+            <a:ext cx="2148840" cy="510540"/>
+          </a:xfrm>
+          <a:prstGeom prst="rect">
+            <a:avLst/>
+          </a:prstGeom>
+          <a:noFill/>
+        </p:spPr>
+        <p:txBody>
+          <a:bodyPr wrap="square">
+            <a:spAutoFit/>
+          </a:bodyPr>
+          <a:lstStyle/>
+          <a:p>
+            <a:pPr algn="l"/>
+            <a:r>
+              <a:rPr sz="900" b="0" i="0">
                 <a:solidFill>
                   <a:srgbClr val="000000"/>
                 </a:solidFill>
@@ -11173,8 +11173,8 @@
         </p:nvSpPr>
         <p:spPr>
           <a:xfrm>
-            <a:off x="9692640" y="3988308"/>
-            <a:ext cx="2194560" cy="548640"/>
+            <a:off x="9619488" y="5160264"/>
+            <a:ext cx="2221992" cy="739140"/>
           </a:xfrm>
           <a:prstGeom prst="rect">
             <a:avLst/>
@@ -11216,8 +11216,8 @@
         </p:nvSpPr>
         <p:spPr>
           <a:xfrm>
-            <a:off x="9756648" y="4015740"/>
-            <a:ext cx="2194560" cy="128016"/>
+            <a:off x="9692640" y="5196840"/>
+            <a:ext cx="2221992" cy="137160"/>
           </a:xfrm>
           <a:prstGeom prst="rect">
             <a:avLst/>
@@ -11251,23 +11251,23 @@
         </p:nvSpPr>
         <p:spPr>
           <a:xfrm>
-            <a:off x="9756648" y="4152900"/>
-            <a:ext cx="2121408" cy="365760"/>
-          </a:xfrm>
-          <a:prstGeom prst="rect">
-            <a:avLst/>
-          </a:prstGeom>
-          <a:noFill/>
-        </p:spPr>
-        <p:txBody>
-          <a:bodyPr wrap="square">
-            <a:spAutoFit/>
-          </a:bodyPr>
-          <a:lstStyle/>
-          <a:p>
-            <a:pPr algn="l"/>
-            <a:r>
-              <a:rPr sz="800" b="0" i="0">
+            <a:off x="9692640" y="5361432"/>
+            <a:ext cx="2148840" cy="510540"/>
+          </a:xfrm>
+          <a:prstGeom prst="rect">
+            <a:avLst/>
+          </a:prstGeom>
+          <a:noFill/>
+        </p:spPr>
+        <p:txBody>
+          <a:bodyPr wrap="square">
+            <a:spAutoFit/>
+          </a:bodyPr>
+          <a:lstStyle/>
+          <a:p>
+            <a:pPr algn="l"/>
+            <a:r>
+              <a:rPr sz="900" b="0" i="0">
                 <a:solidFill>
                   <a:srgbClr val="000000"/>
                 </a:solidFill>
@@ -11286,7 +11286,7 @@
         </p:nvSpPr>
         <p:spPr>
           <a:xfrm>
-            <a:off x="0" y="4576318"/>
+            <a:off x="0" y="5947918"/>
             <a:ext cx="12188952" cy="6350"/>
           </a:xfrm>
           <a:prstGeom prst="rect">
@@ -11329,8 +11329,8 @@
         </p:nvSpPr>
         <p:spPr>
           <a:xfrm>
-            <a:off x="0" y="4582668"/>
-            <a:ext cx="12188952" cy="640080"/>
+            <a:off x="0" y="5954268"/>
+            <a:ext cx="12188952" cy="848868"/>
           </a:xfrm>
           <a:prstGeom prst="rect">
             <a:avLst/>
@@ -11372,8 +11372,8 @@
         </p:nvSpPr>
         <p:spPr>
           <a:xfrm>
-            <a:off x="256032" y="4619244"/>
-            <a:ext cx="4773168" cy="146304"/>
+            <a:off x="292608" y="6009132"/>
+            <a:ext cx="4562856" cy="164592"/>
           </a:xfrm>
           <a:prstGeom prst="rect">
             <a:avLst/>
@@ -11407,23 +11407,23 @@
         </p:nvSpPr>
         <p:spPr>
           <a:xfrm>
-            <a:off x="256032" y="4783836"/>
-            <a:ext cx="4773168" cy="420624"/>
-          </a:xfrm>
-          <a:prstGeom prst="rect">
-            <a:avLst/>
-          </a:prstGeom>
-          <a:noFill/>
-        </p:spPr>
-        <p:txBody>
-          <a:bodyPr wrap="square">
-            <a:spAutoFit/>
-          </a:bodyPr>
-          <a:lstStyle/>
-          <a:p>
-            <a:pPr algn="l"/>
-            <a:r>
-              <a:rPr sz="800" b="0" i="0">
+            <a:off x="292608" y="6210300"/>
+            <a:ext cx="4562856" cy="537972"/>
+          </a:xfrm>
+          <a:prstGeom prst="rect">
+            <a:avLst/>
+          </a:prstGeom>
+          <a:noFill/>
+        </p:spPr>
+        <p:txBody>
+          <a:bodyPr wrap="square">
+            <a:spAutoFit/>
+          </a:bodyPr>
+          <a:lstStyle/>
+          <a:p>
+            <a:pPr algn="l"/>
+            <a:r>
+              <a:rPr sz="900" b="0" i="0">
                 <a:solidFill>
                   <a:srgbClr val="595959"/>
                 </a:solidFill>
@@ -11442,8 +11442,8 @@
         </p:nvSpPr>
         <p:spPr>
           <a:xfrm>
-            <a:off x="5120640" y="4628388"/>
-            <a:ext cx="2194560" cy="548640"/>
+            <a:off x="4956048" y="6009132"/>
+            <a:ext cx="2221992" cy="739140"/>
           </a:xfrm>
           <a:prstGeom prst="rect">
             <a:avLst/>
@@ -11485,8 +11485,8 @@
         </p:nvSpPr>
         <p:spPr>
           <a:xfrm>
-            <a:off x="5184648" y="4655820"/>
-            <a:ext cx="2194560" cy="128016"/>
+            <a:off x="5029200" y="6045708"/>
+            <a:ext cx="2221992" cy="137160"/>
           </a:xfrm>
           <a:prstGeom prst="rect">
             <a:avLst/>
@@ -11520,23 +11520,23 @@
         </p:nvSpPr>
         <p:spPr>
           <a:xfrm>
-            <a:off x="5184648" y="4792980"/>
-            <a:ext cx="2121408" cy="365760"/>
-          </a:xfrm>
-          <a:prstGeom prst="rect">
-            <a:avLst/>
-          </a:prstGeom>
-          <a:noFill/>
-        </p:spPr>
-        <p:txBody>
-          <a:bodyPr wrap="square">
-            <a:spAutoFit/>
-          </a:bodyPr>
-          <a:lstStyle/>
-          <a:p>
-            <a:pPr algn="l"/>
-            <a:r>
-              <a:rPr sz="800" b="0" i="0">
+            <a:off x="5029200" y="6210300"/>
+            <a:ext cx="2148840" cy="510540"/>
+          </a:xfrm>
+          <a:prstGeom prst="rect">
+            <a:avLst/>
+          </a:prstGeom>
+          <a:noFill/>
+        </p:spPr>
+        <p:txBody>
+          <a:bodyPr wrap="square">
+            <a:spAutoFit/>
+          </a:bodyPr>
+          <a:lstStyle/>
+          <a:p>
+            <a:pPr algn="l"/>
+            <a:r>
+              <a:rPr sz="900" b="0" i="0">
                 <a:solidFill>
                   <a:srgbClr val="000000"/>
                 </a:solidFill>
@@ -11555,8 +11555,8 @@
         </p:nvSpPr>
         <p:spPr>
           <a:xfrm>
-            <a:off x="7406640" y="4628388"/>
-            <a:ext cx="2194560" cy="548640"/>
+            <a:off x="7287768" y="6009132"/>
+            <a:ext cx="2221992" cy="739140"/>
           </a:xfrm>
           <a:prstGeom prst="rect">
             <a:avLst/>
@@ -11598,8 +11598,8 @@
         </p:nvSpPr>
         <p:spPr>
           <a:xfrm>
-            <a:off x="7470648" y="4655820"/>
-            <a:ext cx="2194560" cy="128016"/>
+            <a:off x="7360920" y="6045708"/>
+            <a:ext cx="2221992" cy="137160"/>
           </a:xfrm>
           <a:prstGeom prst="rect">
             <a:avLst/>
@@ -11633,23 +11633,23 @@
         </p:nvSpPr>
         <p:spPr>
           <a:xfrm>
-            <a:off x="7470648" y="4792980"/>
-            <a:ext cx="2121408" cy="365760"/>
-          </a:xfrm>
-          <a:prstGeom prst="rect">
-            <a:avLst/>
-          </a:prstGeom>
-          <a:noFill/>
-        </p:spPr>
-        <p:txBody>
-          <a:bodyPr wrap="square">
-            <a:spAutoFit/>
-          </a:bodyPr>
-          <a:lstStyle/>
-          <a:p>
-            <a:pPr algn="l"/>
-            <a:r>
-              <a:rPr sz="800" b="0" i="0">
+            <a:off x="7360920" y="6210300"/>
+            <a:ext cx="2148840" cy="510540"/>
+          </a:xfrm>
+          <a:prstGeom prst="rect">
+            <a:avLst/>
+          </a:prstGeom>
+          <a:noFill/>
+        </p:spPr>
+        <p:txBody>
+          <a:bodyPr wrap="square">
+            <a:spAutoFit/>
+          </a:bodyPr>
+          <a:lstStyle/>
+          <a:p>
+            <a:pPr algn="l"/>
+            <a:r>
+              <a:rPr sz="900" b="0" i="0">
                 <a:solidFill>
                   <a:srgbClr val="000000"/>
                 </a:solidFill>
@@ -11668,8 +11668,8 @@
         </p:nvSpPr>
         <p:spPr>
           <a:xfrm>
-            <a:off x="9692640" y="4628388"/>
-            <a:ext cx="2194560" cy="548640"/>
+            <a:off x="9619488" y="6009132"/>
+            <a:ext cx="2221992" cy="739140"/>
           </a:xfrm>
           <a:prstGeom prst="rect">
             <a:avLst/>
@@ -11711,8 +11711,8 @@
         </p:nvSpPr>
         <p:spPr>
           <a:xfrm>
-            <a:off x="9756648" y="4655820"/>
-            <a:ext cx="2194560" cy="128016"/>
+            <a:off x="9692640" y="6045708"/>
+            <a:ext cx="2221992" cy="137160"/>
           </a:xfrm>
           <a:prstGeom prst="rect">
             <a:avLst/>
@@ -11746,23 +11746,23 @@
         </p:nvSpPr>
         <p:spPr>
           <a:xfrm>
-            <a:off x="9756648" y="4792980"/>
-            <a:ext cx="2121408" cy="365760"/>
-          </a:xfrm>
-          <a:prstGeom prst="rect">
-            <a:avLst/>
-          </a:prstGeom>
-          <a:noFill/>
-        </p:spPr>
-        <p:txBody>
-          <a:bodyPr wrap="square">
-            <a:spAutoFit/>
-          </a:bodyPr>
-          <a:lstStyle/>
-          <a:p>
-            <a:pPr algn="l"/>
-            <a:r>
-              <a:rPr sz="800" b="0" i="0">
+            <a:off x="9692640" y="6210300"/>
+            <a:ext cx="2148840" cy="510540"/>
+          </a:xfrm>
+          <a:prstGeom prst="rect">
+            <a:avLst/>
+          </a:prstGeom>
+          <a:noFill/>
+        </p:spPr>
+        <p:txBody>
+          <a:bodyPr wrap="square">
+            <a:spAutoFit/>
+          </a:bodyPr>
+          <a:lstStyle/>
+          <a:p>
+            <a:pPr algn="l"/>
+            <a:r>
+              <a:rPr sz="900" b="0" i="0">
                 <a:solidFill>
                   <a:srgbClr val="000000"/>
                 </a:solidFill>
@@ -11781,7 +11781,7 @@
         </p:nvSpPr>
         <p:spPr>
           <a:xfrm>
-            <a:off x="0" y="5216398"/>
+            <a:off x="0" y="6796786"/>
             <a:ext cx="12188952" cy="6350"/>
           </a:xfrm>
           <a:prstGeom prst="rect">
@@ -11886,7 +11886,7 @@
         <p:spPr>
           <a:xfrm>
             <a:off x="0" y="0"/>
-            <a:ext cx="12188952" cy="256032"/>
+            <a:ext cx="12188952" cy="292608"/>
           </a:xfrm>
           <a:prstGeom prst="rect">
             <a:avLst/>
@@ -11928,7 +11928,7 @@
         </p:nvSpPr>
         <p:spPr>
           <a:xfrm>
-            <a:off x="0" y="256032"/>
+            <a:off x="0" y="292608"/>
             <a:ext cx="12188952" cy="25400"/>
           </a:xfrm>
           <a:prstGeom prst="rect">
@@ -11971,23 +11971,23 @@
         </p:nvSpPr>
         <p:spPr>
           <a:xfrm>
-            <a:off x="256032" y="45720"/>
-            <a:ext cx="7315200" cy="256032"/>
-          </a:xfrm>
-          <a:prstGeom prst="rect">
-            <a:avLst/>
-          </a:prstGeom>
-          <a:noFill/>
-        </p:spPr>
-        <p:txBody>
-          <a:bodyPr wrap="square">
-            <a:spAutoFit/>
-          </a:bodyPr>
-          <a:lstStyle/>
-          <a:p>
-            <a:pPr algn="l"/>
-            <a:r>
-              <a:rPr sz="800" b="0" i="0">
+            <a:off x="292608" y="64008"/>
+            <a:ext cx="7315200" cy="292608"/>
+          </a:xfrm>
+          <a:prstGeom prst="rect">
+            <a:avLst/>
+          </a:prstGeom>
+          <a:noFill/>
+        </p:spPr>
+        <p:txBody>
+          <a:bodyPr wrap="square">
+            <a:spAutoFit/>
+          </a:bodyPr>
+          <a:lstStyle/>
+          <a:p>
+            <a:pPr algn="l"/>
+            <a:r>
+              <a:rPr sz="900" b="0" i="0">
                 <a:solidFill>
                   <a:srgbClr val="FFFFFF"/>
                 </a:solidFill>
@@ -12006,8 +12006,8 @@
         </p:nvSpPr>
         <p:spPr>
           <a:xfrm>
-            <a:off x="11548872" y="45720"/>
-            <a:ext cx="457200" cy="256032"/>
+            <a:off x="11548872" y="64008"/>
+            <a:ext cx="457200" cy="292608"/>
           </a:xfrm>
           <a:prstGeom prst="rect">
             <a:avLst/>
@@ -12041,8 +12041,8 @@
         </p:nvSpPr>
         <p:spPr>
           <a:xfrm>
-            <a:off x="0" y="294132"/>
-            <a:ext cx="12188952" cy="201168"/>
+            <a:off x="0" y="330708"/>
+            <a:ext cx="12188952" cy="237744"/>
           </a:xfrm>
           <a:prstGeom prst="rect">
             <a:avLst/>
@@ -12084,23 +12084,23 @@
         </p:nvSpPr>
         <p:spPr>
           <a:xfrm>
-            <a:off x="256032" y="321564"/>
-            <a:ext cx="4818888" cy="201168"/>
-          </a:xfrm>
-          <a:prstGeom prst="rect">
-            <a:avLst/>
-          </a:prstGeom>
-          <a:noFill/>
-        </p:spPr>
-        <p:txBody>
-          <a:bodyPr wrap="square">
-            <a:spAutoFit/>
-          </a:bodyPr>
-          <a:lstStyle/>
-          <a:p>
-            <a:pPr algn="l"/>
-            <a:r>
-              <a:rPr sz="800" b="1" i="0">
+            <a:off x="292608" y="367284"/>
+            <a:ext cx="4608576" cy="201168"/>
+          </a:xfrm>
+          <a:prstGeom prst="rect">
+            <a:avLst/>
+          </a:prstGeom>
+          <a:noFill/>
+        </p:spPr>
+        <p:txBody>
+          <a:bodyPr wrap="square">
+            <a:spAutoFit/>
+          </a:bodyPr>
+          <a:lstStyle/>
+          <a:p>
+            <a:pPr algn="l"/>
+            <a:r>
+              <a:rPr sz="900" b="1" i="0">
                 <a:solidFill>
                   <a:srgbClr val="FFFFFF"/>
                 </a:solidFill>
@@ -12119,8 +12119,8 @@
         </p:nvSpPr>
         <p:spPr>
           <a:xfrm>
-            <a:off x="0" y="495300"/>
-            <a:ext cx="12188952" cy="640080"/>
+            <a:off x="0" y="568452"/>
+            <a:ext cx="12188952" cy="1463040"/>
           </a:xfrm>
           <a:prstGeom prst="rect">
             <a:avLst/>
@@ -12162,8 +12162,8 @@
         </p:nvSpPr>
         <p:spPr>
           <a:xfrm>
-            <a:off x="256032" y="531876"/>
-            <a:ext cx="4773168" cy="146304"/>
+            <a:off x="292608" y="623316"/>
+            <a:ext cx="4562856" cy="164592"/>
           </a:xfrm>
           <a:prstGeom prst="rect">
             <a:avLst/>
@@ -12197,23 +12197,23 @@
         </p:nvSpPr>
         <p:spPr>
           <a:xfrm>
-            <a:off x="256032" y="696468"/>
-            <a:ext cx="4773168" cy="420624"/>
-          </a:xfrm>
-          <a:prstGeom prst="rect">
-            <a:avLst/>
-          </a:prstGeom>
-          <a:noFill/>
-        </p:spPr>
-        <p:txBody>
-          <a:bodyPr wrap="square">
-            <a:spAutoFit/>
-          </a:bodyPr>
-          <a:lstStyle/>
-          <a:p>
-            <a:pPr algn="l"/>
-            <a:r>
-              <a:rPr sz="800" b="0" i="0">
+            <a:off x="292608" y="824484"/>
+            <a:ext cx="4562856" cy="1152144"/>
+          </a:xfrm>
+          <a:prstGeom prst="rect">
+            <a:avLst/>
+          </a:prstGeom>
+          <a:noFill/>
+        </p:spPr>
+        <p:txBody>
+          <a:bodyPr wrap="square">
+            <a:spAutoFit/>
+          </a:bodyPr>
+          <a:lstStyle/>
+          <a:p>
+            <a:pPr algn="l"/>
+            <a:r>
+              <a:rPr sz="1000" b="0" i="0">
                 <a:solidFill>
                   <a:srgbClr val="595959"/>
                 </a:solidFill>
@@ -12232,8 +12232,8 @@
         </p:nvSpPr>
         <p:spPr>
           <a:xfrm>
-            <a:off x="5120640" y="541020"/>
-            <a:ext cx="2194560" cy="548640"/>
+            <a:off x="4956048" y="623316"/>
+            <a:ext cx="2221992" cy="1353312"/>
           </a:xfrm>
           <a:prstGeom prst="rect">
             <a:avLst/>
@@ -12275,8 +12275,8 @@
         </p:nvSpPr>
         <p:spPr>
           <a:xfrm>
-            <a:off x="5184648" y="568452"/>
-            <a:ext cx="2194560" cy="128016"/>
+            <a:off x="5029200" y="659892"/>
+            <a:ext cx="2221992" cy="137160"/>
           </a:xfrm>
           <a:prstGeom prst="rect">
             <a:avLst/>
@@ -12310,23 +12310,23 @@
         </p:nvSpPr>
         <p:spPr>
           <a:xfrm>
-            <a:off x="5184648" y="705612"/>
-            <a:ext cx="2121408" cy="365760"/>
-          </a:xfrm>
-          <a:prstGeom prst="rect">
-            <a:avLst/>
-          </a:prstGeom>
-          <a:noFill/>
-        </p:spPr>
-        <p:txBody>
-          <a:bodyPr wrap="square">
-            <a:spAutoFit/>
-          </a:bodyPr>
-          <a:lstStyle/>
-          <a:p>
-            <a:pPr algn="l"/>
-            <a:r>
-              <a:rPr sz="800" b="0" i="0">
+            <a:off x="5029200" y="824484"/>
+            <a:ext cx="2148840" cy="1124712"/>
+          </a:xfrm>
+          <a:prstGeom prst="rect">
+            <a:avLst/>
+          </a:prstGeom>
+          <a:noFill/>
+        </p:spPr>
+        <p:txBody>
+          <a:bodyPr wrap="square">
+            <a:spAutoFit/>
+          </a:bodyPr>
+          <a:lstStyle/>
+          <a:p>
+            <a:pPr algn="l"/>
+            <a:r>
+              <a:rPr sz="1000" b="0" i="0">
                 <a:solidFill>
                   <a:srgbClr val="000000"/>
                 </a:solidFill>
@@ -12345,8 +12345,8 @@
         </p:nvSpPr>
         <p:spPr>
           <a:xfrm>
-            <a:off x="7406640" y="541020"/>
-            <a:ext cx="2194560" cy="548640"/>
+            <a:off x="7287768" y="623316"/>
+            <a:ext cx="2221992" cy="1353312"/>
           </a:xfrm>
           <a:prstGeom prst="rect">
             <a:avLst/>
@@ -12388,8 +12388,8 @@
         </p:nvSpPr>
         <p:spPr>
           <a:xfrm>
-            <a:off x="7470648" y="568452"/>
-            <a:ext cx="2194560" cy="128016"/>
+            <a:off x="7360920" y="659892"/>
+            <a:ext cx="2221992" cy="137160"/>
           </a:xfrm>
           <a:prstGeom prst="rect">
             <a:avLst/>
@@ -12423,23 +12423,23 @@
         </p:nvSpPr>
         <p:spPr>
           <a:xfrm>
-            <a:off x="7470648" y="705612"/>
-            <a:ext cx="2121408" cy="365760"/>
-          </a:xfrm>
-          <a:prstGeom prst="rect">
-            <a:avLst/>
-          </a:prstGeom>
-          <a:noFill/>
-        </p:spPr>
-        <p:txBody>
-          <a:bodyPr wrap="square">
-            <a:spAutoFit/>
-          </a:bodyPr>
-          <a:lstStyle/>
-          <a:p>
-            <a:pPr algn="l"/>
-            <a:r>
-              <a:rPr sz="800" b="0" i="0">
+            <a:off x="7360920" y="824484"/>
+            <a:ext cx="2148840" cy="1124712"/>
+          </a:xfrm>
+          <a:prstGeom prst="rect">
+            <a:avLst/>
+          </a:prstGeom>
+          <a:noFill/>
+        </p:spPr>
+        <p:txBody>
+          <a:bodyPr wrap="square">
+            <a:spAutoFit/>
+          </a:bodyPr>
+          <a:lstStyle/>
+          <a:p>
+            <a:pPr algn="l"/>
+            <a:r>
+              <a:rPr sz="1000" b="0" i="0">
                 <a:solidFill>
                   <a:srgbClr val="000000"/>
                 </a:solidFill>
@@ -12458,8 +12458,8 @@
         </p:nvSpPr>
         <p:spPr>
           <a:xfrm>
-            <a:off x="9692640" y="541020"/>
-            <a:ext cx="2194560" cy="548640"/>
+            <a:off x="9619488" y="623316"/>
+            <a:ext cx="2221992" cy="1353312"/>
           </a:xfrm>
           <a:prstGeom prst="rect">
             <a:avLst/>
@@ -12501,8 +12501,8 @@
         </p:nvSpPr>
         <p:spPr>
           <a:xfrm>
-            <a:off x="9756648" y="568452"/>
-            <a:ext cx="2194560" cy="128016"/>
+            <a:off x="9692640" y="659892"/>
+            <a:ext cx="2221992" cy="137160"/>
           </a:xfrm>
           <a:prstGeom prst="rect">
             <a:avLst/>
@@ -12536,23 +12536,23 @@
         </p:nvSpPr>
         <p:spPr>
           <a:xfrm>
-            <a:off x="9756648" y="705612"/>
-            <a:ext cx="2121408" cy="365760"/>
-          </a:xfrm>
-          <a:prstGeom prst="rect">
-            <a:avLst/>
-          </a:prstGeom>
-          <a:noFill/>
-        </p:spPr>
-        <p:txBody>
-          <a:bodyPr wrap="square">
-            <a:spAutoFit/>
-          </a:bodyPr>
-          <a:lstStyle/>
-          <a:p>
-            <a:pPr algn="l"/>
-            <a:r>
-              <a:rPr sz="800" b="0" i="0">
+            <a:off x="9692640" y="824484"/>
+            <a:ext cx="2148840" cy="1124712"/>
+          </a:xfrm>
+          <a:prstGeom prst="rect">
+            <a:avLst/>
+          </a:prstGeom>
+          <a:noFill/>
+        </p:spPr>
+        <p:txBody>
+          <a:bodyPr wrap="square">
+            <a:spAutoFit/>
+          </a:bodyPr>
+          <a:lstStyle/>
+          <a:p>
+            <a:pPr algn="l"/>
+            <a:r>
+              <a:rPr sz="1000" b="0" i="0">
                 <a:solidFill>
                   <a:srgbClr val="000000"/>
                 </a:solidFill>
@@ -12571,7 +12571,7 @@
         </p:nvSpPr>
         <p:spPr>
           <a:xfrm>
-            <a:off x="0" y="1129030"/>
+            <a:off x="0" y="2025142"/>
             <a:ext cx="12188952" cy="6350"/>
           </a:xfrm>
           <a:prstGeom prst="rect">
@@ -12614,8 +12614,8 @@
         </p:nvSpPr>
         <p:spPr>
           <a:xfrm>
-            <a:off x="0" y="1135380"/>
-            <a:ext cx="12188952" cy="640080"/>
+            <a:off x="0" y="2031492"/>
+            <a:ext cx="12188952" cy="1463040"/>
           </a:xfrm>
           <a:prstGeom prst="rect">
             <a:avLst/>
@@ -12657,8 +12657,8 @@
         </p:nvSpPr>
         <p:spPr>
           <a:xfrm>
-            <a:off x="256032" y="1171956"/>
-            <a:ext cx="4773168" cy="146304"/>
+            <a:off x="292608" y="2086356"/>
+            <a:ext cx="4562856" cy="164592"/>
           </a:xfrm>
           <a:prstGeom prst="rect">
             <a:avLst/>
@@ -12692,23 +12692,23 @@
         </p:nvSpPr>
         <p:spPr>
           <a:xfrm>
-            <a:off x="256032" y="1336548"/>
-            <a:ext cx="4773168" cy="420624"/>
-          </a:xfrm>
-          <a:prstGeom prst="rect">
-            <a:avLst/>
-          </a:prstGeom>
-          <a:noFill/>
-        </p:spPr>
-        <p:txBody>
-          <a:bodyPr wrap="square">
-            <a:spAutoFit/>
-          </a:bodyPr>
-          <a:lstStyle/>
-          <a:p>
-            <a:pPr algn="l"/>
-            <a:r>
-              <a:rPr sz="800" b="0" i="0">
+            <a:off x="292608" y="2287524"/>
+            <a:ext cx="4562856" cy="1152144"/>
+          </a:xfrm>
+          <a:prstGeom prst="rect">
+            <a:avLst/>
+          </a:prstGeom>
+          <a:noFill/>
+        </p:spPr>
+        <p:txBody>
+          <a:bodyPr wrap="square">
+            <a:spAutoFit/>
+          </a:bodyPr>
+          <a:lstStyle/>
+          <a:p>
+            <a:pPr algn="l"/>
+            <a:r>
+              <a:rPr sz="1000" b="0" i="0">
                 <a:solidFill>
                   <a:srgbClr val="595959"/>
                 </a:solidFill>
@@ -12727,8 +12727,8 @@
         </p:nvSpPr>
         <p:spPr>
           <a:xfrm>
-            <a:off x="5120640" y="1181100"/>
-            <a:ext cx="2194560" cy="548640"/>
+            <a:off x="4956048" y="2086356"/>
+            <a:ext cx="2221992" cy="1353312"/>
           </a:xfrm>
           <a:prstGeom prst="rect">
             <a:avLst/>
@@ -12770,8 +12770,8 @@
         </p:nvSpPr>
         <p:spPr>
           <a:xfrm>
-            <a:off x="5184648" y="1208532"/>
-            <a:ext cx="2194560" cy="128016"/>
+            <a:off x="5029200" y="2122932"/>
+            <a:ext cx="2221992" cy="137160"/>
           </a:xfrm>
           <a:prstGeom prst="rect">
             <a:avLst/>
@@ -12805,23 +12805,23 @@
         </p:nvSpPr>
         <p:spPr>
           <a:xfrm>
-            <a:off x="5184648" y="1345692"/>
-            <a:ext cx="2121408" cy="365760"/>
-          </a:xfrm>
-          <a:prstGeom prst="rect">
-            <a:avLst/>
-          </a:prstGeom>
-          <a:noFill/>
-        </p:spPr>
-        <p:txBody>
-          <a:bodyPr wrap="square">
-            <a:spAutoFit/>
-          </a:bodyPr>
-          <a:lstStyle/>
-          <a:p>
-            <a:pPr algn="l"/>
-            <a:r>
-              <a:rPr sz="800" b="0" i="0">
+            <a:off x="5029200" y="2287524"/>
+            <a:ext cx="2148840" cy="1124712"/>
+          </a:xfrm>
+          <a:prstGeom prst="rect">
+            <a:avLst/>
+          </a:prstGeom>
+          <a:noFill/>
+        </p:spPr>
+        <p:txBody>
+          <a:bodyPr wrap="square">
+            <a:spAutoFit/>
+          </a:bodyPr>
+          <a:lstStyle/>
+          <a:p>
+            <a:pPr algn="l"/>
+            <a:r>
+              <a:rPr sz="1000" b="0" i="0">
                 <a:solidFill>
                   <a:srgbClr val="000000"/>
                 </a:solidFill>
@@ -12840,8 +12840,8 @@
         </p:nvSpPr>
         <p:spPr>
           <a:xfrm>
-            <a:off x="7406640" y="1181100"/>
-            <a:ext cx="2194560" cy="548640"/>
+            <a:off x="7287768" y="2086356"/>
+            <a:ext cx="2221992" cy="1353312"/>
           </a:xfrm>
           <a:prstGeom prst="rect">
             <a:avLst/>
@@ -12883,8 +12883,8 @@
         </p:nvSpPr>
         <p:spPr>
           <a:xfrm>
-            <a:off x="7470648" y="1208532"/>
-            <a:ext cx="2194560" cy="128016"/>
+            <a:off x="7360920" y="2122932"/>
+            <a:ext cx="2221992" cy="137160"/>
           </a:xfrm>
           <a:prstGeom prst="rect">
             <a:avLst/>
@@ -12918,23 +12918,23 @@
         </p:nvSpPr>
         <p:spPr>
           <a:xfrm>
-            <a:off x="7470648" y="1345692"/>
-            <a:ext cx="2121408" cy="365760"/>
-          </a:xfrm>
-          <a:prstGeom prst="rect">
-            <a:avLst/>
-          </a:prstGeom>
-          <a:noFill/>
-        </p:spPr>
-        <p:txBody>
-          <a:bodyPr wrap="square">
-            <a:spAutoFit/>
-          </a:bodyPr>
-          <a:lstStyle/>
-          <a:p>
-            <a:pPr algn="l"/>
-            <a:r>
-              <a:rPr sz="800" b="0" i="0">
+            <a:off x="7360920" y="2287524"/>
+            <a:ext cx="2148840" cy="1124712"/>
+          </a:xfrm>
+          <a:prstGeom prst="rect">
+            <a:avLst/>
+          </a:prstGeom>
+          <a:noFill/>
+        </p:spPr>
+        <p:txBody>
+          <a:bodyPr wrap="square">
+            <a:spAutoFit/>
+          </a:bodyPr>
+          <a:lstStyle/>
+          <a:p>
+            <a:pPr algn="l"/>
+            <a:r>
+              <a:rPr sz="1000" b="0" i="0">
                 <a:solidFill>
                   <a:srgbClr val="000000"/>
                 </a:solidFill>
@@ -12953,8 +12953,8 @@
         </p:nvSpPr>
         <p:spPr>
           <a:xfrm>
-            <a:off x="9692640" y="1181100"/>
-            <a:ext cx="2194560" cy="548640"/>
+            <a:off x="9619488" y="2086356"/>
+            <a:ext cx="2221992" cy="1353312"/>
           </a:xfrm>
           <a:prstGeom prst="rect">
             <a:avLst/>
@@ -12996,8 +12996,8 @@
         </p:nvSpPr>
         <p:spPr>
           <a:xfrm>
-            <a:off x="9756648" y="1208532"/>
-            <a:ext cx="2194560" cy="128016"/>
+            <a:off x="9692640" y="2122932"/>
+            <a:ext cx="2221992" cy="137160"/>
           </a:xfrm>
           <a:prstGeom prst="rect">
             <a:avLst/>
@@ -13031,23 +13031,23 @@
         </p:nvSpPr>
         <p:spPr>
           <a:xfrm>
-            <a:off x="9756648" y="1345692"/>
-            <a:ext cx="2121408" cy="365760"/>
-          </a:xfrm>
-          <a:prstGeom prst="rect">
-            <a:avLst/>
-          </a:prstGeom>
-          <a:noFill/>
-        </p:spPr>
-        <p:txBody>
-          <a:bodyPr wrap="square">
-            <a:spAutoFit/>
-          </a:bodyPr>
-          <a:lstStyle/>
-          <a:p>
-            <a:pPr algn="l"/>
-            <a:r>
-              <a:rPr sz="800" b="0" i="0">
+            <a:off x="9692640" y="2287524"/>
+            <a:ext cx="2148840" cy="1124712"/>
+          </a:xfrm>
+          <a:prstGeom prst="rect">
+            <a:avLst/>
+          </a:prstGeom>
+          <a:noFill/>
+        </p:spPr>
+        <p:txBody>
+          <a:bodyPr wrap="square">
+            <a:spAutoFit/>
+          </a:bodyPr>
+          <a:lstStyle/>
+          <a:p>
+            <a:pPr algn="l"/>
+            <a:r>
+              <a:rPr sz="1000" b="0" i="0">
                 <a:solidFill>
                   <a:srgbClr val="000000"/>
                 </a:solidFill>
@@ -13066,7 +13066,7 @@
         </p:nvSpPr>
         <p:spPr>
           <a:xfrm>
-            <a:off x="0" y="1769110"/>
+            <a:off x="0" y="3488182"/>
             <a:ext cx="12188952" cy="6350"/>
           </a:xfrm>
           <a:prstGeom prst="rect">

</xml_diff>